<commit_message>
docs(tutorial): code-review deck — list ALL 30 findings, not just 1 per category
Fix mismatch between deck claims and deck content: cover slide reported
"30 findings, 10 HIGH, 6 CleanCore blockers" but the per-category slides
only showed 1 representative finding each. Looked like we were either
miscounting or hiding findings.

Restructured stages 4-7. Each category now gets a slide with a complete
table of every finding in that category (#, severity tag, title,
location) plus one representative snippet below for context:

- Slide 4 — All 6 CleanCore findings (all HIGH)
- Slide 5 — All 4 Security findings (2 HIGH, 1 MEDIUM, 1 LOW)
- Slide 6 — All 4 Performance findings (2 HIGH, 2 MEDIUM)
- Slide 7 — All 16 Maintainability findings (all LOW)

Total: 30 findings listed verbatim with their source-of-truth locations
from the per-check .md files. Nothing hidden.

Co-Authored-By: Claude Opus 4.7 (1M context) <noreply@anthropic.com>
</commit_message>
<xml_diff>
--- a/docs/tutorials/code-review/examples/ZDMS_UPLOAD_FILES/report.pptx
+++ b/docs/tutorials/code-review/examples/ZDMS_UPLOAD_FILES/report.pptx
@@ -13,7 +13,6 @@
     <p:sldId id="261" r:id="rId12"/>
     <p:sldId id="262" r:id="rId13"/>
     <p:sldId id="263" r:id="rId14"/>
-    <p:sldId id="264" r:id="rId15"/>
   </p:sldIdLst>
   <p:sldSz cx="12188952" cy="6858000" type="screen4x3"/>
   <p:notesSz cx="6858000" cy="9144000"/>
@@ -3285,7 +3284,7 @@
               </a:defRPr>
             </a:pPr>
             <a:r>
-              <a:t>Package Z001 · destination DS4_CLH · 4 parallel category checks</a:t>
+              <a:t>Package Z001 · destination DS4_CLH · 4 parallel category checks · 30 findings, all listed</a:t>
             </a:r>
           </a:p>
         </p:txBody>
@@ -3476,7 +3475,7 @@
               </a:defRPr>
             </a:pPr>
             <a:r>
-              <a:t>Headline counts and severity profile</a:t>
+              <a:t>Headline counts + severity profile</a:t>
             </a:r>
           </a:p>
         </p:txBody>
@@ -3762,7 +3761,7 @@
               </a:defRPr>
             </a:pPr>
             <a:r>
-              <a:t>• Every finding below anchored to a verbatim ABAP snippet from source.</a:t>
+              <a:t>• All 30 findings listed by category on the following slides — nothing hidden.</a:t>
             </a:r>
           </a:p>
         </p:txBody>
@@ -4891,7 +4890,7 @@
               </a:defRPr>
             </a:pPr>
             <a:r>
-              <a:t>Highest-impact for migration: CleanCore — 100% HIGH severity, blocks S/4HANA Cloud.</a:t>
+              <a:t>Highest-impact: CleanCore — 100% HIGH severity, blocks S/4HANA Cloud.</a:t>
             </a:r>
           </a:p>
           <a:p>
@@ -4918,6 +4917,29 @@
             </a:pPr>
             <a:r>
               <a:t>0 CRITICAL: legacy code has no immediate data-loss / breach risk, just compliance and perf drift.</a:t>
+            </a:r>
+          </a:p>
+          <a:p>
+            <a:pPr>
+              <a:defRPr sz="1200" b="0">
+                <a:solidFill>
+                  <a:srgbClr val="333333"/>
+                </a:solidFill>
+                <a:latin typeface="Calibri"/>
+              </a:defRPr>
+            </a:pPr>
+          </a:p>
+          <a:p>
+            <a:pPr>
+              <a:defRPr sz="1200" b="0">
+                <a:solidFill>
+                  <a:srgbClr val="333333"/>
+                </a:solidFill>
+                <a:latin typeface="Calibri"/>
+              </a:defRPr>
+            </a:pPr>
+            <a:r>
+              <a:t>Next slides — every finding listed by category, with location and severity tag.</a:t>
             </a:r>
           </a:p>
         </p:txBody>
@@ -5086,7 +5108,7 @@
               </a:defRPr>
             </a:pPr>
             <a:r>
-              <a:t>SXPG OS shell access</a:t>
+              <a:t>All CleanCore findings</a:t>
             </a:r>
           </a:p>
           <a:p>
@@ -5104,47 +5126,725 @@
               </a:defRPr>
             </a:pPr>
             <a:r>
-              <a:t>Top CleanCore finding</a:t>
-            </a:r>
-          </a:p>
-        </p:txBody>
-      </p:sp>
-      <p:sp>
-        <p:nvSpPr>
-          <p:cNvPr id="5" name="TextBox 4"/>
-          <p:cNvSpPr txBox="1"/>
+              <a:t>6 findings — all HIGH, all blockers</a:t>
+            </a:r>
+          </a:p>
+        </p:txBody>
+      </p:sp>
+      <p:graphicFrame>
+        <p:nvGraphicFramePr>
+          <p:cNvPr id="5" name="Table 4"/>
+          <p:cNvGraphicFramePr>
+            <a:graphicFrameLocks noGrp="1"/>
+          </p:cNvGraphicFramePr>
           <p:nvPr/>
-        </p:nvSpPr>
-        <p:spPr>
-          <a:xfrm>
-            <a:off x="3200400" y="457200"/>
-            <a:ext cx="8869680" cy="365760"/>
-          </a:xfrm>
-          <a:prstGeom prst="rect">
-            <a:avLst/>
-          </a:prstGeom>
-          <a:noFill/>
-        </p:spPr>
-        <p:txBody>
-          <a:bodyPr wrap="square">
-            <a:spAutoFit/>
-          </a:bodyPr>
-          <a:lstStyle/>
-          <a:p>
-            <a:pPr>
-              <a:defRPr sz="1400" b="1">
-                <a:solidFill>
-                  <a:srgbClr val="C83636"/>
-                </a:solidFill>
-                <a:latin typeface="Calibri"/>
-              </a:defRPr>
-            </a:pPr>
-            <a:r>
-              <a:t>HIGH — OS command execution via `SXPG_COMMAND_EXECUTE` (shell access)</a:t>
-            </a:r>
-          </a:p>
-        </p:txBody>
-      </p:sp>
+        </p:nvGraphicFramePr>
+        <p:xfrm>
+          <a:off x="3200400" y="640080"/>
+          <a:ext cx="8869680" cy="4114800"/>
+        </p:xfrm>
+        <a:graphic>
+          <a:graphicData uri="http://schemas.openxmlformats.org/drawingml/2006/table">
+            <a:tbl>
+              <a:tblPr firstRow="1" bandRow="1">
+                <a:tableStyleId>{5C22544A-7EE6-4342-B048-85BDC9FD1C3A}</a:tableStyleId>
+              </a:tblPr>
+              <a:tblGrid>
+                <a:gridCol w="365760"/>
+                <a:gridCol w="640080"/>
+                <a:gridCol w="5029200"/>
+                <a:gridCol w="2834640"/>
+              </a:tblGrid>
+              <a:tr h="587828">
+                <a:tc>
+                  <a:txBody>
+                    <a:bodyPr/>
+                    <a:lstStyle/>
+                    <a:p>
+                      <a:pPr>
+                        <a:defRPr sz="1000" b="1">
+                          <a:solidFill>
+                            <a:srgbClr val="FFFFFF"/>
+                          </a:solidFill>
+                          <a:latin typeface="Calibri"/>
+                        </a:defRPr>
+                      </a:pPr>
+                      <a:r>
+                        <a:t>#</a:t>
+                      </a:r>
+                    </a:p>
+                  </a:txBody>
+                  <a:tcPr>
+                    <a:solidFill>
+                      <a:srgbClr val="161616"/>
+                    </a:solidFill>
+                  </a:tcPr>
+                </a:tc>
+                <a:tc>
+                  <a:txBody>
+                    <a:bodyPr/>
+                    <a:lstStyle/>
+                    <a:p>
+                      <a:pPr>
+                        <a:defRPr sz="1000" b="1">
+                          <a:solidFill>
+                            <a:srgbClr val="FFFFFF"/>
+                          </a:solidFill>
+                          <a:latin typeface="Calibri"/>
+                        </a:defRPr>
+                      </a:pPr>
+                      <a:r>
+                        <a:t>Sev</a:t>
+                      </a:r>
+                    </a:p>
+                  </a:txBody>
+                  <a:tcPr>
+                    <a:solidFill>
+                      <a:srgbClr val="161616"/>
+                    </a:solidFill>
+                  </a:tcPr>
+                </a:tc>
+                <a:tc>
+                  <a:txBody>
+                    <a:bodyPr/>
+                    <a:lstStyle/>
+                    <a:p>
+                      <a:pPr>
+                        <a:defRPr sz="1000" b="1">
+                          <a:solidFill>
+                            <a:srgbClr val="FFFFFF"/>
+                          </a:solidFill>
+                          <a:latin typeface="Calibri"/>
+                        </a:defRPr>
+                      </a:pPr>
+                      <a:r>
+                        <a:t>Finding title</a:t>
+                      </a:r>
+                    </a:p>
+                  </a:txBody>
+                  <a:tcPr>
+                    <a:solidFill>
+                      <a:srgbClr val="161616"/>
+                    </a:solidFill>
+                  </a:tcPr>
+                </a:tc>
+                <a:tc>
+                  <a:txBody>
+                    <a:bodyPr/>
+                    <a:lstStyle/>
+                    <a:p>
+                      <a:pPr>
+                        <a:defRPr sz="1000" b="1">
+                          <a:solidFill>
+                            <a:srgbClr val="FFFFFF"/>
+                          </a:solidFill>
+                          <a:latin typeface="Calibri"/>
+                        </a:defRPr>
+                      </a:pPr>
+                      <a:r>
+                        <a:t>Location</a:t>
+                      </a:r>
+                    </a:p>
+                  </a:txBody>
+                  <a:tcPr>
+                    <a:solidFill>
+                      <a:srgbClr val="161616"/>
+                    </a:solidFill>
+                  </a:tcPr>
+                </a:tc>
+              </a:tr>
+              <a:tr h="587828">
+                <a:tc>
+                  <a:txBody>
+                    <a:bodyPr/>
+                    <a:lstStyle/>
+                    <a:p>
+                      <a:pPr>
+                        <a:defRPr sz="900">
+                          <a:solidFill>
+                            <a:srgbClr val="333333"/>
+                          </a:solidFill>
+                          <a:latin typeface="Calibri"/>
+                        </a:defRPr>
+                      </a:pPr>
+                      <a:r>
+                        <a:t>1</a:t>
+                      </a:r>
+                    </a:p>
+                  </a:txBody>
+                  <a:tcPr>
+                    <a:solidFill>
+                      <a:srgbClr val="FFFFFF"/>
+                    </a:solidFill>
+                  </a:tcPr>
+                </a:tc>
+                <a:tc>
+                  <a:txBody>
+                    <a:bodyPr/>
+                    <a:lstStyle/>
+                    <a:p>
+                      <a:pPr>
+                        <a:defRPr sz="900" b="1">
+                          <a:solidFill>
+                            <a:srgbClr val="E67E22"/>
+                          </a:solidFill>
+                          <a:latin typeface="Calibri"/>
+                        </a:defRPr>
+                      </a:pPr>
+                      <a:r>
+                        <a:t>HIGH</a:t>
+                      </a:r>
+                    </a:p>
+                  </a:txBody>
+                  <a:tcPr>
+                    <a:solidFill>
+                      <a:srgbClr val="FFFFFF"/>
+                    </a:solidFill>
+                  </a:tcPr>
+                </a:tc>
+                <a:tc>
+                  <a:txBody>
+                    <a:bodyPr/>
+                    <a:lstStyle/>
+                    <a:p>
+                      <a:pPr>
+                        <a:defRPr sz="900">
+                          <a:solidFill>
+                            <a:srgbClr val="333333"/>
+                          </a:solidFill>
+                          <a:latin typeface="Calibri"/>
+                        </a:defRPr>
+                      </a:pPr>
+                      <a:r>
+                        <a:t>OS command execution via `SXPG_COMMAND_EXECUTE` (shell access)</a:t>
+                      </a:r>
+                    </a:p>
+                  </a:txBody>
+                  <a:tcPr>
+                    <a:solidFill>
+                      <a:srgbClr val="FFFFFF"/>
+                    </a:solidFill>
+                  </a:tcPr>
+                </a:tc>
+                <a:tc>
+                  <a:txBody>
+                    <a:bodyPr/>
+                    <a:lstStyle/>
+                    <a:p>
+                      <a:pPr>
+                        <a:defRPr sz="900">
+                          <a:solidFill>
+                            <a:srgbClr val="333333"/>
+                          </a:solidFill>
+                          <a:latin typeface="Consolas"/>
+                        </a:defRPr>
+                      </a:pPr>
+                      <a:r>
+                        <a:t>ZDMS_UPLOAD_FILES_F01:~325</a:t>
+                      </a:r>
+                    </a:p>
+                  </a:txBody>
+                  <a:tcPr>
+                    <a:solidFill>
+                      <a:srgbClr val="FFFFFF"/>
+                    </a:solidFill>
+                  </a:tcPr>
+                </a:tc>
+              </a:tr>
+              <a:tr h="587828">
+                <a:tc>
+                  <a:txBody>
+                    <a:bodyPr/>
+                    <a:lstStyle/>
+                    <a:p>
+                      <a:pPr>
+                        <a:defRPr sz="900">
+                          <a:solidFill>
+                            <a:srgbClr val="333333"/>
+                          </a:solidFill>
+                          <a:latin typeface="Calibri"/>
+                        </a:defRPr>
+                      </a:pPr>
+                      <a:r>
+                        <a:t>2</a:t>
+                      </a:r>
+                    </a:p>
+                  </a:txBody>
+                  <a:tcPr>
+                    <a:solidFill>
+                      <a:srgbClr val="F5F5F5"/>
+                    </a:solidFill>
+                  </a:tcPr>
+                </a:tc>
+                <a:tc>
+                  <a:txBody>
+                    <a:bodyPr/>
+                    <a:lstStyle/>
+                    <a:p>
+                      <a:pPr>
+                        <a:defRPr sz="900" b="1">
+                          <a:solidFill>
+                            <a:srgbClr val="E67E22"/>
+                          </a:solidFill>
+                          <a:latin typeface="Calibri"/>
+                        </a:defRPr>
+                      </a:pPr>
+                      <a:r>
+                        <a:t>HIGH</a:t>
+                      </a:r>
+                    </a:p>
+                  </a:txBody>
+                  <a:tcPr>
+                    <a:solidFill>
+                      <a:srgbClr val="F5F5F5"/>
+                    </a:solidFill>
+                  </a:tcPr>
+                </a:tc>
+                <a:tc>
+                  <a:txBody>
+                    <a:bodyPr/>
+                    <a:lstStyle/>
+                    <a:p>
+                      <a:pPr>
+                        <a:defRPr sz="900">
+                          <a:solidFill>
+                            <a:srgbClr val="333333"/>
+                          </a:solidFill>
+                          <a:latin typeface="Calibri"/>
+                        </a:defRPr>
+                      </a:pPr>
+                      <a:r>
+                        <a:t>OS command execution via `SXPG_COMMAND_EXECUTE` (shell access)</a:t>
+                      </a:r>
+                    </a:p>
+                  </a:txBody>
+                  <a:tcPr>
+                    <a:solidFill>
+                      <a:srgbClr val="F5F5F5"/>
+                    </a:solidFill>
+                  </a:tcPr>
+                </a:tc>
+                <a:tc>
+                  <a:txBody>
+                    <a:bodyPr/>
+                    <a:lstStyle/>
+                    <a:p>
+                      <a:pPr>
+                        <a:defRPr sz="900">
+                          <a:solidFill>
+                            <a:srgbClr val="333333"/>
+                          </a:solidFill>
+                          <a:latin typeface="Consolas"/>
+                        </a:defRPr>
+                      </a:pPr>
+                      <a:r>
+                        <a:t>ZDMS_UPLOAD_FILES_F01:~388</a:t>
+                      </a:r>
+                    </a:p>
+                  </a:txBody>
+                  <a:tcPr>
+                    <a:solidFill>
+                      <a:srgbClr val="F5F5F5"/>
+                    </a:solidFill>
+                  </a:tcPr>
+                </a:tc>
+              </a:tr>
+              <a:tr h="587828">
+                <a:tc>
+                  <a:txBody>
+                    <a:bodyPr/>
+                    <a:lstStyle/>
+                    <a:p>
+                      <a:pPr>
+                        <a:defRPr sz="900">
+                          <a:solidFill>
+                            <a:srgbClr val="333333"/>
+                          </a:solidFill>
+                          <a:latin typeface="Calibri"/>
+                        </a:defRPr>
+                      </a:pPr>
+                      <a:r>
+                        <a:t>3</a:t>
+                      </a:r>
+                    </a:p>
+                  </a:txBody>
+                  <a:tcPr>
+                    <a:solidFill>
+                      <a:srgbClr val="FFFFFF"/>
+                    </a:solidFill>
+                  </a:tcPr>
+                </a:tc>
+                <a:tc>
+                  <a:txBody>
+                    <a:bodyPr/>
+                    <a:lstStyle/>
+                    <a:p>
+                      <a:pPr>
+                        <a:defRPr sz="900" b="1">
+                          <a:solidFill>
+                            <a:srgbClr val="E67E22"/>
+                          </a:solidFill>
+                          <a:latin typeface="Calibri"/>
+                        </a:defRPr>
+                      </a:pPr>
+                      <a:r>
+                        <a:t>HIGH</a:t>
+                      </a:r>
+                    </a:p>
+                  </a:txBody>
+                  <a:tcPr>
+                    <a:solidFill>
+                      <a:srgbClr val="FFFFFF"/>
+                    </a:solidFill>
+                  </a:tcPr>
+                </a:tc>
+                <a:tc>
+                  <a:txBody>
+                    <a:bodyPr/>
+                    <a:lstStyle/>
+                    <a:p>
+                      <a:pPr>
+                        <a:defRPr sz="900">
+                          <a:solidFill>
+                            <a:srgbClr val="333333"/>
+                          </a:solidFill>
+                          <a:latin typeface="Calibri"/>
+                        </a:defRPr>
+                      </a:pPr>
+                      <a:r>
+                        <a:t>File operations on application server via `OPEN DATASET` / `READ DATASET` / `TRANSFER` / `DELETE DATASET` (AL11-style)</a:t>
+                      </a:r>
+                    </a:p>
+                  </a:txBody>
+                  <a:tcPr>
+                    <a:solidFill>
+                      <a:srgbClr val="FFFFFF"/>
+                    </a:solidFill>
+                  </a:tcPr>
+                </a:tc>
+                <a:tc>
+                  <a:txBody>
+                    <a:bodyPr/>
+                    <a:lstStyle/>
+                    <a:p>
+                      <a:pPr>
+                        <a:defRPr sz="900">
+                          <a:solidFill>
+                            <a:srgbClr val="333333"/>
+                          </a:solidFill>
+                          <a:latin typeface="Consolas"/>
+                        </a:defRPr>
+                      </a:pPr>
+                      <a:r>
+                        <a:t>ZDMS_UPLOAD_FILES_F01:~468</a:t>
+                      </a:r>
+                    </a:p>
+                  </a:txBody>
+                  <a:tcPr>
+                    <a:solidFill>
+                      <a:srgbClr val="FFFFFF"/>
+                    </a:solidFill>
+                  </a:tcPr>
+                </a:tc>
+              </a:tr>
+              <a:tr h="587828">
+                <a:tc>
+                  <a:txBody>
+                    <a:bodyPr/>
+                    <a:lstStyle/>
+                    <a:p>
+                      <a:pPr>
+                        <a:defRPr sz="900">
+                          <a:solidFill>
+                            <a:srgbClr val="333333"/>
+                          </a:solidFill>
+                          <a:latin typeface="Calibri"/>
+                        </a:defRPr>
+                      </a:pPr>
+                      <a:r>
+                        <a:t>4</a:t>
+                      </a:r>
+                    </a:p>
+                  </a:txBody>
+                  <a:tcPr>
+                    <a:solidFill>
+                      <a:srgbClr val="F5F5F5"/>
+                    </a:solidFill>
+                  </a:tcPr>
+                </a:tc>
+                <a:tc>
+                  <a:txBody>
+                    <a:bodyPr/>
+                    <a:lstStyle/>
+                    <a:p>
+                      <a:pPr>
+                        <a:defRPr sz="900" b="1">
+                          <a:solidFill>
+                            <a:srgbClr val="E67E22"/>
+                          </a:solidFill>
+                          <a:latin typeface="Calibri"/>
+                        </a:defRPr>
+                      </a:pPr>
+                      <a:r>
+                        <a:t>HIGH</a:t>
+                      </a:r>
+                    </a:p>
+                  </a:txBody>
+                  <a:tcPr>
+                    <a:solidFill>
+                      <a:srgbClr val="F5F5F5"/>
+                    </a:solidFill>
+                  </a:tcPr>
+                </a:tc>
+                <a:tc>
+                  <a:txBody>
+                    <a:bodyPr/>
+                    <a:lstStyle/>
+                    <a:p>
+                      <a:pPr>
+                        <a:defRPr sz="900">
+                          <a:solidFill>
+                            <a:srgbClr val="333333"/>
+                          </a:solidFill>
+                          <a:latin typeface="Calibri"/>
+                        </a:defRPr>
+                      </a:pPr>
+                      <a:r>
+                        <a:t>File deletion on application server via `DELETE DATASET` (AL11-style)</a:t>
+                      </a:r>
+                    </a:p>
+                  </a:txBody>
+                  <a:tcPr>
+                    <a:solidFill>
+                      <a:srgbClr val="F5F5F5"/>
+                    </a:solidFill>
+                  </a:tcPr>
+                </a:tc>
+                <a:tc>
+                  <a:txBody>
+                    <a:bodyPr/>
+                    <a:lstStyle/>
+                    <a:p>
+                      <a:pPr>
+                        <a:defRPr sz="900">
+                          <a:solidFill>
+                            <a:srgbClr val="333333"/>
+                          </a:solidFill>
+                          <a:latin typeface="Consolas"/>
+                        </a:defRPr>
+                      </a:pPr>
+                      <a:r>
+                        <a:t>ZDMS_UPLOAD_FILES_F01:~494</a:t>
+                      </a:r>
+                    </a:p>
+                  </a:txBody>
+                  <a:tcPr>
+                    <a:solidFill>
+                      <a:srgbClr val="F5F5F5"/>
+                    </a:solidFill>
+                  </a:tcPr>
+                </a:tc>
+              </a:tr>
+              <a:tr h="587828">
+                <a:tc>
+                  <a:txBody>
+                    <a:bodyPr/>
+                    <a:lstStyle/>
+                    <a:p>
+                      <a:pPr>
+                        <a:defRPr sz="900">
+                          <a:solidFill>
+                            <a:srgbClr val="333333"/>
+                          </a:solidFill>
+                          <a:latin typeface="Calibri"/>
+                        </a:defRPr>
+                      </a:pPr>
+                      <a:r>
+                        <a:t>5</a:t>
+                      </a:r>
+                    </a:p>
+                  </a:txBody>
+                  <a:tcPr>
+                    <a:solidFill>
+                      <a:srgbClr val="FFFFFF"/>
+                    </a:solidFill>
+                  </a:tcPr>
+                </a:tc>
+                <a:tc>
+                  <a:txBody>
+                    <a:bodyPr/>
+                    <a:lstStyle/>
+                    <a:p>
+                      <a:pPr>
+                        <a:defRPr sz="900" b="1">
+                          <a:solidFill>
+                            <a:srgbClr val="E67E22"/>
+                          </a:solidFill>
+                          <a:latin typeface="Calibri"/>
+                        </a:defRPr>
+                      </a:pPr>
+                      <a:r>
+                        <a:t>HIGH</a:t>
+                      </a:r>
+                    </a:p>
+                  </a:txBody>
+                  <a:tcPr>
+                    <a:solidFill>
+                      <a:srgbClr val="FFFFFF"/>
+                    </a:solidFill>
+                  </a:tcPr>
+                </a:tc>
+                <a:tc>
+                  <a:txBody>
+                    <a:bodyPr/>
+                    <a:lstStyle/>
+                    <a:p>
+                      <a:pPr>
+                        <a:defRPr sz="900">
+                          <a:solidFill>
+                            <a:srgbClr val="333333"/>
+                          </a:solidFill>
+                          <a:latin typeface="Calibri"/>
+                        </a:defRPr>
+                      </a:pPr>
+                      <a:r>
+                        <a:t>File deletion on application server via `DELETE DATASET` (AL11-style)</a:t>
+                      </a:r>
+                    </a:p>
+                  </a:txBody>
+                  <a:tcPr>
+                    <a:solidFill>
+                      <a:srgbClr val="FFFFFF"/>
+                    </a:solidFill>
+                  </a:tcPr>
+                </a:tc>
+                <a:tc>
+                  <a:txBody>
+                    <a:bodyPr/>
+                    <a:lstStyle/>
+                    <a:p>
+                      <a:pPr>
+                        <a:defRPr sz="900">
+                          <a:solidFill>
+                            <a:srgbClr val="333333"/>
+                          </a:solidFill>
+                          <a:latin typeface="Consolas"/>
+                        </a:defRPr>
+                      </a:pPr>
+                      <a:r>
+                        <a:t>ZDMS_UPLOAD_FILES_F01:~656</a:t>
+                      </a:r>
+                    </a:p>
+                  </a:txBody>
+                  <a:tcPr>
+                    <a:solidFill>
+                      <a:srgbClr val="FFFFFF"/>
+                    </a:solidFill>
+                  </a:tcPr>
+                </a:tc>
+              </a:tr>
+              <a:tr h="587832">
+                <a:tc>
+                  <a:txBody>
+                    <a:bodyPr/>
+                    <a:lstStyle/>
+                    <a:p>
+                      <a:pPr>
+                        <a:defRPr sz="900">
+                          <a:solidFill>
+                            <a:srgbClr val="333333"/>
+                          </a:solidFill>
+                          <a:latin typeface="Calibri"/>
+                        </a:defRPr>
+                      </a:pPr>
+                      <a:r>
+                        <a:t>6</a:t>
+                      </a:r>
+                    </a:p>
+                  </a:txBody>
+                  <a:tcPr>
+                    <a:solidFill>
+                      <a:srgbClr val="F5F5F5"/>
+                    </a:solidFill>
+                  </a:tcPr>
+                </a:tc>
+                <a:tc>
+                  <a:txBody>
+                    <a:bodyPr/>
+                    <a:lstStyle/>
+                    <a:p>
+                      <a:pPr>
+                        <a:defRPr sz="900" b="1">
+                          <a:solidFill>
+                            <a:srgbClr val="E67E22"/>
+                          </a:solidFill>
+                          <a:latin typeface="Calibri"/>
+                        </a:defRPr>
+                      </a:pPr>
+                      <a:r>
+                        <a:t>HIGH</a:t>
+                      </a:r>
+                    </a:p>
+                  </a:txBody>
+                  <a:tcPr>
+                    <a:solidFill>
+                      <a:srgbClr val="F5F5F5"/>
+                    </a:solidFill>
+                  </a:tcPr>
+                </a:tc>
+                <a:tc>
+                  <a:txBody>
+                    <a:bodyPr/>
+                    <a:lstStyle/>
+                    <a:p>
+                      <a:pPr>
+                        <a:defRPr sz="900">
+                          <a:solidFill>
+                            <a:srgbClr val="333333"/>
+                          </a:solidFill>
+                          <a:latin typeface="Calibri"/>
+                        </a:defRPr>
+                      </a:pPr>
+                      <a:r>
+                        <a:t>Direct read of standard table `TVARVC` (released API alternative expected)</a:t>
+                      </a:r>
+                    </a:p>
+                  </a:txBody>
+                  <a:tcPr>
+                    <a:solidFill>
+                      <a:srgbClr val="F5F5F5"/>
+                    </a:solidFill>
+                  </a:tcPr>
+                </a:tc>
+                <a:tc>
+                  <a:txBody>
+                    <a:bodyPr/>
+                    <a:lstStyle/>
+                    <a:p>
+                      <a:pPr>
+                        <a:defRPr sz="900">
+                          <a:solidFill>
+                            <a:srgbClr val="333333"/>
+                          </a:solidFill>
+                          <a:latin typeface="Consolas"/>
+                        </a:defRPr>
+                      </a:pPr>
+                      <a:r>
+                        <a:t>ZDMS_UPLOAD_FILES_F01:~164</a:t>
+                      </a:r>
+                    </a:p>
+                  </a:txBody>
+                  <a:tcPr>
+                    <a:solidFill>
+                      <a:srgbClr val="F5F5F5"/>
+                    </a:solidFill>
+                  </a:tcPr>
+                </a:tc>
+              </a:tr>
+            </a:tbl>
+          </a:graphicData>
+        </a:graphic>
+      </p:graphicFrame>
       <p:sp>
         <p:nvSpPr>
           <p:cNvPr id="6" name="TextBox 5"/>
@@ -5153,7 +5853,7 @@
         </p:nvSpPr>
         <p:spPr>
           <a:xfrm>
-            <a:off x="3200400" y="868680"/>
+            <a:off x="3200400" y="5029200"/>
             <a:ext cx="8869680" cy="274320"/>
           </a:xfrm>
           <a:prstGeom prst="rect">
@@ -5168,15 +5868,15 @@
           <a:lstStyle/>
           <a:p>
             <a:pPr>
-              <a:defRPr sz="1000" b="0">
-                <a:solidFill>
-                  <a:srgbClr val="555555"/>
+              <a:defRPr sz="1000" b="1">
+                <a:solidFill>
+                  <a:srgbClr val="C83636"/>
                 </a:solidFill>
                 <a:latin typeface="Calibri"/>
               </a:defRPr>
             </a:pPr>
             <a:r>
-              <a:t>Source: ZDMS_UPLOAD_FILES_F01:~325</a:t>
+              <a:t>Representative #1: OS command execution via `SXPG_COMMAND_EXECUTE` (shell access)</a:t>
             </a:r>
           </a:p>
         </p:txBody>
@@ -5189,8 +5889,8 @@
         </p:nvSpPr>
         <p:spPr>
           <a:xfrm>
-            <a:off x="3200400" y="1280160"/>
-            <a:ext cx="8869680" cy="2286000"/>
+            <a:off x="3200400" y="5394960"/>
+            <a:ext cx="8869680" cy="1097280"/>
           </a:xfrm>
           <a:prstGeom prst="rect">
             <a:avLst/>
@@ -5206,7 +5906,7 @@
           <a:lstStyle/>
           <a:p>
             <a:pPr>
-              <a:defRPr sz="1200" b="0">
+              <a:defRPr sz="1000" b="0">
                 <a:solidFill>
                   <a:srgbClr val="333333"/>
                 </a:solidFill>
@@ -5219,7 +5919,7 @@
           </a:p>
           <a:p>
             <a:pPr>
-              <a:defRPr sz="1200" b="0">
+              <a:defRPr sz="1000" b="0">
                 <a:solidFill>
                   <a:srgbClr val="333333"/>
                 </a:solidFill>
@@ -5232,7 +5932,7 @@
           </a:p>
           <a:p>
             <a:pPr>
-              <a:defRPr sz="1200" b="0">
+              <a:defRPr sz="1000" b="0">
                 <a:solidFill>
                   <a:srgbClr val="333333"/>
                 </a:solidFill>
@@ -5245,7 +5945,7 @@
           </a:p>
           <a:p>
             <a:pPr>
-              <a:defRPr sz="1200" b="0">
+              <a:defRPr sz="1000" b="0">
                 <a:solidFill>
                   <a:srgbClr val="333333"/>
                 </a:solidFill>
@@ -5261,78 +5961,6 @@
       <p:sp>
         <p:nvSpPr>
           <p:cNvPr id="8" name="TextBox 7"/>
-          <p:cNvSpPr txBox="1"/>
-          <p:nvPr/>
-        </p:nvSpPr>
-        <p:spPr>
-          <a:xfrm>
-            <a:off x="3200400" y="4023360"/>
-            <a:ext cx="8869680" cy="914400"/>
-          </a:xfrm>
-          <a:prstGeom prst="rect">
-            <a:avLst/>
-          </a:prstGeom>
-          <a:noFill/>
-        </p:spPr>
-        <p:txBody>
-          <a:bodyPr wrap="square">
-            <a:spAutoFit/>
-          </a:bodyPr>
-          <a:lstStyle/>
-          <a:p>
-            <a:pPr>
-              <a:defRPr sz="1100" b="0">
-                <a:solidFill>
-                  <a:srgbClr val="333333"/>
-                </a:solidFill>
-                <a:latin typeface="Calibri"/>
-              </a:defRPr>
-            </a:pPr>
-            <a:r>
-              <a:t>Why: Executing external OS commands is not allowed for S/4HANA Clean Core / Cloud (shell access via SM69 commands).</a:t>
-            </a:r>
-          </a:p>
-        </p:txBody>
-      </p:sp>
-      <p:sp>
-        <p:nvSpPr>
-          <p:cNvPr id="9" name="TextBox 8"/>
-          <p:cNvSpPr txBox="1"/>
-          <p:nvPr/>
-        </p:nvSpPr>
-        <p:spPr>
-          <a:xfrm>
-            <a:off x="3200400" y="5303520"/>
-            <a:ext cx="8869680" cy="1097280"/>
-          </a:xfrm>
-          <a:prstGeom prst="rect">
-            <a:avLst/>
-          </a:prstGeom>
-          <a:noFill/>
-        </p:spPr>
-        <p:txBody>
-          <a:bodyPr wrap="square">
-            <a:spAutoFit/>
-          </a:bodyPr>
-          <a:lstStyle/>
-          <a:p>
-            <a:pPr>
-              <a:defRPr sz="1100" b="1">
-                <a:solidFill>
-                  <a:srgbClr val="418DFF"/>
-                </a:solidFill>
-                <a:latin typeface="Calibri"/>
-              </a:defRPr>
-            </a:pPr>
-            <a:r>
-              <a:t>Recommendation: Replace OS-command-based SFTP with a released integration approach (e.g., SAP Integration Suite / Cloud Connector, or an HTTP-based API using released ABAP HTTP clients to a managed endpoint). Avoid SM69/SXPG completely.</a:t>
-            </a:r>
-          </a:p>
-        </p:txBody>
-      </p:sp>
-      <p:sp>
-        <p:nvSpPr>
-          <p:cNvPr id="10" name="TextBox 9"/>
           <p:cNvSpPr txBox="1"/>
           <p:nvPr/>
         </p:nvSpPr>
@@ -5458,7 +6086,7 @@
               </a:defRPr>
             </a:pPr>
             <a:r>
-              <a:t>SECTION 02 · CLEANCORE</a:t>
+              <a:t>SECTION 02 · SECURITY</a:t>
             </a:r>
           </a:p>
         </p:txBody>
@@ -5494,7 +6122,7 @@
               </a:defRPr>
             </a:pPr>
             <a:r>
-              <a:t>AL11 file I/O</a:t>
+              <a:t>All Security findings</a:t>
             </a:r>
           </a:p>
           <a:p>
@@ -5512,47 +6140,529 @@
               </a:defRPr>
             </a:pPr>
             <a:r>
-              <a:t>Second CleanCore finding</a:t>
-            </a:r>
-          </a:p>
-        </p:txBody>
-      </p:sp>
-      <p:sp>
-        <p:nvSpPr>
-          <p:cNvPr id="5" name="TextBox 4"/>
-          <p:cNvSpPr txBox="1"/>
+              <a:t>4 findings (2 HIGH, 1 MEDIUM, 1 LOW)</a:t>
+            </a:r>
+          </a:p>
+        </p:txBody>
+      </p:sp>
+      <p:graphicFrame>
+        <p:nvGraphicFramePr>
+          <p:cNvPr id="5" name="Table 4"/>
+          <p:cNvGraphicFramePr>
+            <a:graphicFrameLocks noGrp="1"/>
+          </p:cNvGraphicFramePr>
           <p:nvPr/>
-        </p:nvSpPr>
-        <p:spPr>
-          <a:xfrm>
-            <a:off x="3200400" y="457200"/>
-            <a:ext cx="8869680" cy="365760"/>
-          </a:xfrm>
-          <a:prstGeom prst="rect">
-            <a:avLst/>
-          </a:prstGeom>
-          <a:noFill/>
-        </p:spPr>
-        <p:txBody>
-          <a:bodyPr wrap="square">
-            <a:spAutoFit/>
-          </a:bodyPr>
-          <a:lstStyle/>
-          <a:p>
-            <a:pPr>
-              <a:defRPr sz="1400" b="1">
-                <a:solidFill>
-                  <a:srgbClr val="C83636"/>
-                </a:solidFill>
-                <a:latin typeface="Calibri"/>
-              </a:defRPr>
-            </a:pPr>
-            <a:r>
-              <a:t>HIGH — OS command execution via `SXPG_COMMAND_EXECUTE` (shell access)</a:t>
-            </a:r>
-          </a:p>
-        </p:txBody>
-      </p:sp>
+        </p:nvGraphicFramePr>
+        <p:xfrm>
+          <a:off x="3200400" y="640080"/>
+          <a:ext cx="8869680" cy="2743200"/>
+        </p:xfrm>
+        <a:graphic>
+          <a:graphicData uri="http://schemas.openxmlformats.org/drawingml/2006/table">
+            <a:tbl>
+              <a:tblPr firstRow="1" bandRow="1">
+                <a:tableStyleId>{5C22544A-7EE6-4342-B048-85BDC9FD1C3A}</a:tableStyleId>
+              </a:tblPr>
+              <a:tblGrid>
+                <a:gridCol w="365760"/>
+                <a:gridCol w="640080"/>
+                <a:gridCol w="5029200"/>
+                <a:gridCol w="2834640"/>
+              </a:tblGrid>
+              <a:tr h="548640">
+                <a:tc>
+                  <a:txBody>
+                    <a:bodyPr/>
+                    <a:lstStyle/>
+                    <a:p>
+                      <a:pPr>
+                        <a:defRPr sz="1000" b="1">
+                          <a:solidFill>
+                            <a:srgbClr val="FFFFFF"/>
+                          </a:solidFill>
+                          <a:latin typeface="Calibri"/>
+                        </a:defRPr>
+                      </a:pPr>
+                      <a:r>
+                        <a:t>#</a:t>
+                      </a:r>
+                    </a:p>
+                  </a:txBody>
+                  <a:tcPr>
+                    <a:solidFill>
+                      <a:srgbClr val="161616"/>
+                    </a:solidFill>
+                  </a:tcPr>
+                </a:tc>
+                <a:tc>
+                  <a:txBody>
+                    <a:bodyPr/>
+                    <a:lstStyle/>
+                    <a:p>
+                      <a:pPr>
+                        <a:defRPr sz="1000" b="1">
+                          <a:solidFill>
+                            <a:srgbClr val="FFFFFF"/>
+                          </a:solidFill>
+                          <a:latin typeface="Calibri"/>
+                        </a:defRPr>
+                      </a:pPr>
+                      <a:r>
+                        <a:t>Sev</a:t>
+                      </a:r>
+                    </a:p>
+                  </a:txBody>
+                  <a:tcPr>
+                    <a:solidFill>
+                      <a:srgbClr val="161616"/>
+                    </a:solidFill>
+                  </a:tcPr>
+                </a:tc>
+                <a:tc>
+                  <a:txBody>
+                    <a:bodyPr/>
+                    <a:lstStyle/>
+                    <a:p>
+                      <a:pPr>
+                        <a:defRPr sz="1000" b="1">
+                          <a:solidFill>
+                            <a:srgbClr val="FFFFFF"/>
+                          </a:solidFill>
+                          <a:latin typeface="Calibri"/>
+                        </a:defRPr>
+                      </a:pPr>
+                      <a:r>
+                        <a:t>Finding title</a:t>
+                      </a:r>
+                    </a:p>
+                  </a:txBody>
+                  <a:tcPr>
+                    <a:solidFill>
+                      <a:srgbClr val="161616"/>
+                    </a:solidFill>
+                  </a:tcPr>
+                </a:tc>
+                <a:tc>
+                  <a:txBody>
+                    <a:bodyPr/>
+                    <a:lstStyle/>
+                    <a:p>
+                      <a:pPr>
+                        <a:defRPr sz="1000" b="1">
+                          <a:solidFill>
+                            <a:srgbClr val="FFFFFF"/>
+                          </a:solidFill>
+                          <a:latin typeface="Calibri"/>
+                        </a:defRPr>
+                      </a:pPr>
+                      <a:r>
+                        <a:t>Location</a:t>
+                      </a:r>
+                    </a:p>
+                  </a:txBody>
+                  <a:tcPr>
+                    <a:solidFill>
+                      <a:srgbClr val="161616"/>
+                    </a:solidFill>
+                  </a:tcPr>
+                </a:tc>
+              </a:tr>
+              <a:tr h="548640">
+                <a:tc>
+                  <a:txBody>
+                    <a:bodyPr/>
+                    <a:lstStyle/>
+                    <a:p>
+                      <a:pPr>
+                        <a:defRPr sz="900">
+                          <a:solidFill>
+                            <a:srgbClr val="333333"/>
+                          </a:solidFill>
+                          <a:latin typeface="Calibri"/>
+                        </a:defRPr>
+                      </a:pPr>
+                      <a:r>
+                        <a:t>1</a:t>
+                      </a:r>
+                    </a:p>
+                  </a:txBody>
+                  <a:tcPr>
+                    <a:solidFill>
+                      <a:srgbClr val="FFFFFF"/>
+                    </a:solidFill>
+                  </a:tcPr>
+                </a:tc>
+                <a:tc>
+                  <a:txBody>
+                    <a:bodyPr/>
+                    <a:lstStyle/>
+                    <a:p>
+                      <a:pPr>
+                        <a:defRPr sz="900" b="1">
+                          <a:solidFill>
+                            <a:srgbClr val="E67E22"/>
+                          </a:solidFill>
+                          <a:latin typeface="Calibri"/>
+                        </a:defRPr>
+                      </a:pPr>
+                      <a:r>
+                        <a:t>HIGH</a:t>
+                      </a:r>
+                    </a:p>
+                  </a:txBody>
+                  <a:tcPr>
+                    <a:solidFill>
+                      <a:srgbClr val="FFFFFF"/>
+                    </a:solidFill>
+                  </a:tcPr>
+                </a:tc>
+                <a:tc>
+                  <a:txBody>
+                    <a:bodyPr/>
+                    <a:lstStyle/>
+                    <a:p>
+                      <a:pPr>
+                        <a:defRPr sz="900">
+                          <a:solidFill>
+                            <a:srgbClr val="333333"/>
+                          </a:solidFill>
+                          <a:latin typeface="Calibri"/>
+                        </a:defRPr>
+                      </a:pPr>
+                      <a:r>
+                        <a:t>Missing explicit authorization check before OS command execution (SFTP GET)</a:t>
+                      </a:r>
+                    </a:p>
+                  </a:txBody>
+                  <a:tcPr>
+                    <a:solidFill>
+                      <a:srgbClr val="FFFFFF"/>
+                    </a:solidFill>
+                  </a:tcPr>
+                </a:tc>
+                <a:tc>
+                  <a:txBody>
+                    <a:bodyPr/>
+                    <a:lstStyle/>
+                    <a:p>
+                      <a:pPr>
+                        <a:defRPr sz="900">
+                          <a:solidFill>
+                            <a:srgbClr val="333333"/>
+                          </a:solidFill>
+                          <a:latin typeface="Consolas"/>
+                        </a:defRPr>
+                      </a:pPr>
+                      <a:r>
+                        <a:t>ZDMS_UPLOAD_FILES_F01:~250</a:t>
+                      </a:r>
+                    </a:p>
+                  </a:txBody>
+                  <a:tcPr>
+                    <a:solidFill>
+                      <a:srgbClr val="FFFFFF"/>
+                    </a:solidFill>
+                  </a:tcPr>
+                </a:tc>
+              </a:tr>
+              <a:tr h="548640">
+                <a:tc>
+                  <a:txBody>
+                    <a:bodyPr/>
+                    <a:lstStyle/>
+                    <a:p>
+                      <a:pPr>
+                        <a:defRPr sz="900">
+                          <a:solidFill>
+                            <a:srgbClr val="333333"/>
+                          </a:solidFill>
+                          <a:latin typeface="Calibri"/>
+                        </a:defRPr>
+                      </a:pPr>
+                      <a:r>
+                        <a:t>2</a:t>
+                      </a:r>
+                    </a:p>
+                  </a:txBody>
+                  <a:tcPr>
+                    <a:solidFill>
+                      <a:srgbClr val="F5F5F5"/>
+                    </a:solidFill>
+                  </a:tcPr>
+                </a:tc>
+                <a:tc>
+                  <a:txBody>
+                    <a:bodyPr/>
+                    <a:lstStyle/>
+                    <a:p>
+                      <a:pPr>
+                        <a:defRPr sz="900" b="1">
+                          <a:solidFill>
+                            <a:srgbClr val="E67E22"/>
+                          </a:solidFill>
+                          <a:latin typeface="Calibri"/>
+                        </a:defRPr>
+                      </a:pPr>
+                      <a:r>
+                        <a:t>HIGH</a:t>
+                      </a:r>
+                    </a:p>
+                  </a:txBody>
+                  <a:tcPr>
+                    <a:solidFill>
+                      <a:srgbClr val="F5F5F5"/>
+                    </a:solidFill>
+                  </a:tcPr>
+                </a:tc>
+                <a:tc>
+                  <a:txBody>
+                    <a:bodyPr/>
+                    <a:lstStyle/>
+                    <a:p>
+                      <a:pPr>
+                        <a:defRPr sz="900">
+                          <a:solidFill>
+                            <a:srgbClr val="333333"/>
+                          </a:solidFill>
+                          <a:latin typeface="Calibri"/>
+                        </a:defRPr>
+                      </a:pPr>
+                      <a:r>
+                        <a:t>Missing explicit authorization check before OS command execution (SFTP PUT)</a:t>
+                      </a:r>
+                    </a:p>
+                  </a:txBody>
+                  <a:tcPr>
+                    <a:solidFill>
+                      <a:srgbClr val="F5F5F5"/>
+                    </a:solidFill>
+                  </a:tcPr>
+                </a:tc>
+                <a:tc>
+                  <a:txBody>
+                    <a:bodyPr/>
+                    <a:lstStyle/>
+                    <a:p>
+                      <a:pPr>
+                        <a:defRPr sz="900">
+                          <a:solidFill>
+                            <a:srgbClr val="333333"/>
+                          </a:solidFill>
+                          <a:latin typeface="Consolas"/>
+                        </a:defRPr>
+                      </a:pPr>
+                      <a:r>
+                        <a:t>ZDMS_UPLOAD_FILES_F01:~320</a:t>
+                      </a:r>
+                    </a:p>
+                  </a:txBody>
+                  <a:tcPr>
+                    <a:solidFill>
+                      <a:srgbClr val="F5F5F5"/>
+                    </a:solidFill>
+                  </a:tcPr>
+                </a:tc>
+              </a:tr>
+              <a:tr h="548640">
+                <a:tc>
+                  <a:txBody>
+                    <a:bodyPr/>
+                    <a:lstStyle/>
+                    <a:p>
+                      <a:pPr>
+                        <a:defRPr sz="900">
+                          <a:solidFill>
+                            <a:srgbClr val="333333"/>
+                          </a:solidFill>
+                          <a:latin typeface="Calibri"/>
+                        </a:defRPr>
+                      </a:pPr>
+                      <a:r>
+                        <a:t>3</a:t>
+                      </a:r>
+                    </a:p>
+                  </a:txBody>
+                  <a:tcPr>
+                    <a:solidFill>
+                      <a:srgbClr val="FFFFFF"/>
+                    </a:solidFill>
+                  </a:tcPr>
+                </a:tc>
+                <a:tc>
+                  <a:txBody>
+                    <a:bodyPr/>
+                    <a:lstStyle/>
+                    <a:p>
+                      <a:pPr>
+                        <a:defRPr sz="900" b="1">
+                          <a:solidFill>
+                            <a:srgbClr val="CC9900"/>
+                          </a:solidFill>
+                          <a:latin typeface="Calibri"/>
+                        </a:defRPr>
+                      </a:pPr>
+                      <a:r>
+                        <a:t>MEDIUM</a:t>
+                      </a:r>
+                    </a:p>
+                  </a:txBody>
+                  <a:tcPr>
+                    <a:solidFill>
+                      <a:srgbClr val="FFFFFF"/>
+                    </a:solidFill>
+                  </a:tcPr>
+                </a:tc>
+                <a:tc>
+                  <a:txBody>
+                    <a:bodyPr/>
+                    <a:lstStyle/>
+                    <a:p>
+                      <a:pPr>
+                        <a:defRPr sz="900">
+                          <a:solidFill>
+                            <a:srgbClr val="333333"/>
+                          </a:solidFill>
+                          <a:latin typeface="Calibri"/>
+                        </a:defRPr>
+                      </a:pPr>
+                      <a:r>
+                        <a:t>Shell-injection risk: building `additional_parameters` via concatenation of configurable values</a:t>
+                      </a:r>
+                    </a:p>
+                  </a:txBody>
+                  <a:tcPr>
+                    <a:solidFill>
+                      <a:srgbClr val="FFFFFF"/>
+                    </a:solidFill>
+                  </a:tcPr>
+                </a:tc>
+                <a:tc>
+                  <a:txBody>
+                    <a:bodyPr/>
+                    <a:lstStyle/>
+                    <a:p>
+                      <a:pPr>
+                        <a:defRPr sz="900">
+                          <a:solidFill>
+                            <a:srgbClr val="333333"/>
+                          </a:solidFill>
+                          <a:latin typeface="Consolas"/>
+                        </a:defRPr>
+                      </a:pPr>
+                      <a:r>
+                        <a:t>ZDMS_UPLOAD_FILES_F01:~420</a:t>
+                      </a:r>
+                    </a:p>
+                  </a:txBody>
+                  <a:tcPr>
+                    <a:solidFill>
+                      <a:srgbClr val="FFFFFF"/>
+                    </a:solidFill>
+                  </a:tcPr>
+                </a:tc>
+              </a:tr>
+              <a:tr h="548640">
+                <a:tc>
+                  <a:txBody>
+                    <a:bodyPr/>
+                    <a:lstStyle/>
+                    <a:p>
+                      <a:pPr>
+                        <a:defRPr sz="900">
+                          <a:solidFill>
+                            <a:srgbClr val="333333"/>
+                          </a:solidFill>
+                          <a:latin typeface="Calibri"/>
+                        </a:defRPr>
+                      </a:pPr>
+                      <a:r>
+                        <a:t>4</a:t>
+                      </a:r>
+                    </a:p>
+                  </a:txBody>
+                  <a:tcPr>
+                    <a:solidFill>
+                      <a:srgbClr val="F5F5F5"/>
+                    </a:solidFill>
+                  </a:tcPr>
+                </a:tc>
+                <a:tc>
+                  <a:txBody>
+                    <a:bodyPr/>
+                    <a:lstStyle/>
+                    <a:p>
+                      <a:pPr>
+                        <a:defRPr sz="900" b="1">
+                          <a:solidFill>
+                            <a:srgbClr val="707070"/>
+                          </a:solidFill>
+                          <a:latin typeface="Calibri"/>
+                        </a:defRPr>
+                      </a:pPr>
+                      <a:r>
+                        <a:t>LOW</a:t>
+                      </a:r>
+                    </a:p>
+                  </a:txBody>
+                  <a:tcPr>
+                    <a:solidFill>
+                      <a:srgbClr val="F5F5F5"/>
+                    </a:solidFill>
+                  </a:tcPr>
+                </a:tc>
+                <a:tc>
+                  <a:txBody>
+                    <a:bodyPr/>
+                    <a:lstStyle/>
+                    <a:p>
+                      <a:pPr>
+                        <a:defRPr sz="900">
+                          <a:solidFill>
+                            <a:srgbClr val="333333"/>
+                          </a:solidFill>
+                          <a:latin typeface="Calibri"/>
+                        </a:defRPr>
+                      </a:pPr>
+                      <a:r>
+                        <a:t>Sensitive operational details may be exposed via plain report output</a:t>
+                      </a:r>
+                    </a:p>
+                  </a:txBody>
+                  <a:tcPr>
+                    <a:solidFill>
+                      <a:srgbClr val="F5F5F5"/>
+                    </a:solidFill>
+                  </a:tcPr>
+                </a:tc>
+                <a:tc>
+                  <a:txBody>
+                    <a:bodyPr/>
+                    <a:lstStyle/>
+                    <a:p>
+                      <a:pPr>
+                        <a:defRPr sz="900">
+                          <a:solidFill>
+                            <a:srgbClr val="333333"/>
+                          </a:solidFill>
+                          <a:latin typeface="Consolas"/>
+                        </a:defRPr>
+                      </a:pPr>
+                      <a:r>
+                        <a:t>ZDMS_UPLOAD_FILES_F01:~385</a:t>
+                      </a:r>
+                    </a:p>
+                  </a:txBody>
+                  <a:tcPr>
+                    <a:solidFill>
+                      <a:srgbClr val="F5F5F5"/>
+                    </a:solidFill>
+                  </a:tcPr>
+                </a:tc>
+              </a:tr>
+            </a:tbl>
+          </a:graphicData>
+        </a:graphic>
+      </p:graphicFrame>
       <p:sp>
         <p:nvSpPr>
           <p:cNvPr id="6" name="TextBox 5"/>
@@ -5561,7 +6671,7 @@
         </p:nvSpPr>
         <p:spPr>
           <a:xfrm>
-            <a:off x="3200400" y="868680"/>
+            <a:off x="3200400" y="3657600"/>
             <a:ext cx="8869680" cy="274320"/>
           </a:xfrm>
           <a:prstGeom prst="rect">
@@ -5576,15 +6686,15 @@
           <a:lstStyle/>
           <a:p>
             <a:pPr>
-              <a:defRPr sz="1000" b="0">
-                <a:solidFill>
-                  <a:srgbClr val="555555"/>
+              <a:defRPr sz="1000" b="1">
+                <a:solidFill>
+                  <a:srgbClr val="E67E22"/>
                 </a:solidFill>
                 <a:latin typeface="Calibri"/>
               </a:defRPr>
             </a:pPr>
             <a:r>
-              <a:t>Source: ZDMS_UPLOAD_FILES_F01:~388</a:t>
+              <a:t>Representative #1: Missing explicit authorization check before OS command execution (SFTP GET)</a:t>
             </a:r>
           </a:p>
         </p:txBody>
@@ -5597,8 +6707,8 @@
         </p:nvSpPr>
         <p:spPr>
           <a:xfrm>
-            <a:off x="3200400" y="1280160"/>
-            <a:ext cx="8869680" cy="2286000"/>
+            <a:off x="3200400" y="4023360"/>
+            <a:ext cx="8869680" cy="1280160"/>
           </a:xfrm>
           <a:prstGeom prst="rect">
             <a:avLst/>
@@ -5614,7 +6724,7 @@
           <a:lstStyle/>
           <a:p>
             <a:pPr>
-              <a:defRPr sz="1200" b="0">
+              <a:defRPr sz="1000" b="0">
                 <a:solidFill>
                   <a:srgbClr val="333333"/>
                 </a:solidFill>
@@ -5627,7 +6737,7 @@
           </a:p>
           <a:p>
             <a:pPr>
-              <a:defRPr sz="1200" b="0">
+              <a:defRPr sz="1000" b="0">
                 <a:solidFill>
                   <a:srgbClr val="333333"/>
                 </a:solidFill>
@@ -5640,7 +6750,7 @@
           </a:p>
           <a:p>
             <a:pPr>
-              <a:defRPr sz="1200" b="0">
+              <a:defRPr sz="1000" b="0">
                 <a:solidFill>
                   <a:srgbClr val="333333"/>
                 </a:solidFill>
@@ -5648,12 +6758,12 @@
               </a:defRPr>
             </a:pPr>
             <a:r>
-              <a:t>    commandname                   = lv_comm</a:t>
+              <a:t>    commandname           = lv_comm</a:t>
             </a:r>
           </a:p>
           <a:p>
             <a:pPr>
-              <a:defRPr sz="1200" b="0">
+              <a:defRPr sz="1000" b="0">
                 <a:solidFill>
                   <a:srgbClr val="333333"/>
                 </a:solidFill>
@@ -5661,7 +6771,7 @@
               </a:defRPr>
             </a:pPr>
             <a:r>
-              <a:t>    additional_parameters         = gv_param</a:t>
+              <a:t>    additional_parameters = gv_param</a:t>
             </a:r>
           </a:p>
         </p:txBody>
@@ -5674,8 +6784,8 @@
         </p:nvSpPr>
         <p:spPr>
           <a:xfrm>
-            <a:off x="3200400" y="4023360"/>
-            <a:ext cx="8869680" cy="914400"/>
+            <a:off x="3200400" y="5486400"/>
+            <a:ext cx="8869680" cy="822960"/>
           </a:xfrm>
           <a:prstGeom prst="rect">
             <a:avLst/>
@@ -5689,7 +6799,7 @@
           <a:lstStyle/>
           <a:p>
             <a:pPr>
-              <a:defRPr sz="1100" b="0">
+              <a:defRPr sz="1000" b="0">
                 <a:solidFill>
                   <a:srgbClr val="333333"/>
                 </a:solidFill>
@@ -5697,7 +6807,30 @@
               </a:defRPr>
             </a:pPr>
             <a:r>
-              <a:t>Why: Executing external OS commands is not allowed for S/4HANA Clean Core / Cloud (shell access via SM69 commands).</a:t>
+              <a:t>Why: `SXPG_COMMAND_EXECUTE` triggers execution of an external OS command; there is no explicit `AUTHORITY-CHECK` (e.g., `S_LOG_COM` / `S_RZL_ADM` depending on setup) before this sensitive operation.</a:t>
+            </a:r>
+          </a:p>
+          <a:p>
+            <a:pPr>
+              <a:defRPr sz="1000" b="0">
+                <a:solidFill>
+                  <a:srgbClr val="333333"/>
+                </a:solidFill>
+                <a:latin typeface="Calibri"/>
+              </a:defRPr>
+            </a:pPr>
+          </a:p>
+          <a:p>
+            <a:pPr>
+              <a:defRPr sz="1000" b="0">
+                <a:solidFill>
+                  <a:srgbClr val="333333"/>
+                </a:solidFill>
+                <a:latin typeface="Calibri"/>
+              </a:defRPr>
+            </a:pPr>
+            <a:r>
+              <a:t>Recommendation: Add an explicit `AUTHORITY-CHECK` before calling `SXPG_COMMAND_EXECUTE` (and fail closed). Also restrict allowed commands in SM69 and ensure the command is defined with “Additional parameters not allowed” where possible.</a:t>
             </a:r>
           </a:p>
         </p:txBody>
@@ -5705,42 +6838,6 @@
       <p:sp>
         <p:nvSpPr>
           <p:cNvPr id="9" name="TextBox 8"/>
-          <p:cNvSpPr txBox="1"/>
-          <p:nvPr/>
-        </p:nvSpPr>
-        <p:spPr>
-          <a:xfrm>
-            <a:off x="3200400" y="5303520"/>
-            <a:ext cx="8869680" cy="1097280"/>
-          </a:xfrm>
-          <a:prstGeom prst="rect">
-            <a:avLst/>
-          </a:prstGeom>
-          <a:noFill/>
-        </p:spPr>
-        <p:txBody>
-          <a:bodyPr wrap="square">
-            <a:spAutoFit/>
-          </a:bodyPr>
-          <a:lstStyle/>
-          <a:p>
-            <a:pPr>
-              <a:defRPr sz="1100" b="1">
-                <a:solidFill>
-                  <a:srgbClr val="418DFF"/>
-                </a:solidFill>
-                <a:latin typeface="Calibri"/>
-              </a:defRPr>
-            </a:pPr>
-            <a:r>
-              <a:t>Recommendation: Same as above—move file transfer out of the ABAP app server OS layer and use a released connectivity/integration mechanism.</a:t>
-            </a:r>
-          </a:p>
-        </p:txBody>
-      </p:sp>
-      <p:sp>
-        <p:nvSpPr>
-          <p:cNvPr id="10" name="TextBox 9"/>
           <p:cNvSpPr txBox="1"/>
           <p:nvPr/>
         </p:nvSpPr>
@@ -5866,7 +6963,7 @@
               </a:defRPr>
             </a:pPr>
             <a:r>
-              <a:t>SECTION 02 · SECURITY</a:t>
+              <a:t>SECTION 02 · PERFORMANCE</a:t>
             </a:r>
           </a:p>
         </p:txBody>
@@ -5902,7 +6999,7 @@
               </a:defRPr>
             </a:pPr>
             <a:r>
-              <a:t>Missing AUTHORITY-CHECK</a:t>
+              <a:t>All Performance findings</a:t>
             </a:r>
           </a:p>
           <a:p>
@@ -5920,47 +7017,529 @@
               </a:defRPr>
             </a:pPr>
             <a:r>
-              <a:t>Top security finding</a:t>
-            </a:r>
-          </a:p>
-        </p:txBody>
-      </p:sp>
-      <p:sp>
-        <p:nvSpPr>
-          <p:cNvPr id="5" name="TextBox 4"/>
-          <p:cNvSpPr txBox="1"/>
+              <a:t>4 findings (2 HIGH, 2 MEDIUM)</a:t>
+            </a:r>
+          </a:p>
+        </p:txBody>
+      </p:sp>
+      <p:graphicFrame>
+        <p:nvGraphicFramePr>
+          <p:cNvPr id="5" name="Table 4"/>
+          <p:cNvGraphicFramePr>
+            <a:graphicFrameLocks noGrp="1"/>
+          </p:cNvGraphicFramePr>
           <p:nvPr/>
-        </p:nvSpPr>
-        <p:spPr>
-          <a:xfrm>
-            <a:off x="3200400" y="457200"/>
-            <a:ext cx="8869680" cy="365760"/>
-          </a:xfrm>
-          <a:prstGeom prst="rect">
-            <a:avLst/>
-          </a:prstGeom>
-          <a:noFill/>
-        </p:spPr>
-        <p:txBody>
-          <a:bodyPr wrap="square">
-            <a:spAutoFit/>
-          </a:bodyPr>
-          <a:lstStyle/>
-          <a:p>
-            <a:pPr>
-              <a:defRPr sz="1400" b="1">
-                <a:solidFill>
-                  <a:srgbClr val="C83636"/>
-                </a:solidFill>
-                <a:latin typeface="Calibri"/>
-              </a:defRPr>
-            </a:pPr>
-            <a:r>
-              <a:t>HIGH — Missing explicit authorization check before OS command execution (SFTP GET)</a:t>
-            </a:r>
-          </a:p>
-        </p:txBody>
-      </p:sp>
+        </p:nvGraphicFramePr>
+        <p:xfrm>
+          <a:off x="3200400" y="640080"/>
+          <a:ext cx="8869680" cy="2743200"/>
+        </p:xfrm>
+        <a:graphic>
+          <a:graphicData uri="http://schemas.openxmlformats.org/drawingml/2006/table">
+            <a:tbl>
+              <a:tblPr firstRow="1" bandRow="1">
+                <a:tableStyleId>{5C22544A-7EE6-4342-B048-85BDC9FD1C3A}</a:tableStyleId>
+              </a:tblPr>
+              <a:tblGrid>
+                <a:gridCol w="365760"/>
+                <a:gridCol w="640080"/>
+                <a:gridCol w="5029200"/>
+                <a:gridCol w="2834640"/>
+              </a:tblGrid>
+              <a:tr h="548640">
+                <a:tc>
+                  <a:txBody>
+                    <a:bodyPr/>
+                    <a:lstStyle/>
+                    <a:p>
+                      <a:pPr>
+                        <a:defRPr sz="1000" b="1">
+                          <a:solidFill>
+                            <a:srgbClr val="FFFFFF"/>
+                          </a:solidFill>
+                          <a:latin typeface="Calibri"/>
+                        </a:defRPr>
+                      </a:pPr>
+                      <a:r>
+                        <a:t>#</a:t>
+                      </a:r>
+                    </a:p>
+                  </a:txBody>
+                  <a:tcPr>
+                    <a:solidFill>
+                      <a:srgbClr val="161616"/>
+                    </a:solidFill>
+                  </a:tcPr>
+                </a:tc>
+                <a:tc>
+                  <a:txBody>
+                    <a:bodyPr/>
+                    <a:lstStyle/>
+                    <a:p>
+                      <a:pPr>
+                        <a:defRPr sz="1000" b="1">
+                          <a:solidFill>
+                            <a:srgbClr val="FFFFFF"/>
+                          </a:solidFill>
+                          <a:latin typeface="Calibri"/>
+                        </a:defRPr>
+                      </a:pPr>
+                      <a:r>
+                        <a:t>Sev</a:t>
+                      </a:r>
+                    </a:p>
+                  </a:txBody>
+                  <a:tcPr>
+                    <a:solidFill>
+                      <a:srgbClr val="161616"/>
+                    </a:solidFill>
+                  </a:tcPr>
+                </a:tc>
+                <a:tc>
+                  <a:txBody>
+                    <a:bodyPr/>
+                    <a:lstStyle/>
+                    <a:p>
+                      <a:pPr>
+                        <a:defRPr sz="1000" b="1">
+                          <a:solidFill>
+                            <a:srgbClr val="FFFFFF"/>
+                          </a:solidFill>
+                          <a:latin typeface="Calibri"/>
+                        </a:defRPr>
+                      </a:pPr>
+                      <a:r>
+                        <a:t>Finding title</a:t>
+                      </a:r>
+                    </a:p>
+                  </a:txBody>
+                  <a:tcPr>
+                    <a:solidFill>
+                      <a:srgbClr val="161616"/>
+                    </a:solidFill>
+                  </a:tcPr>
+                </a:tc>
+                <a:tc>
+                  <a:txBody>
+                    <a:bodyPr/>
+                    <a:lstStyle/>
+                    <a:p>
+                      <a:pPr>
+                        <a:defRPr sz="1000" b="1">
+                          <a:solidFill>
+                            <a:srgbClr val="FFFFFF"/>
+                          </a:solidFill>
+                          <a:latin typeface="Calibri"/>
+                        </a:defRPr>
+                      </a:pPr>
+                      <a:r>
+                        <a:t>Location</a:t>
+                      </a:r>
+                    </a:p>
+                  </a:txBody>
+                  <a:tcPr>
+                    <a:solidFill>
+                      <a:srgbClr val="161616"/>
+                    </a:solidFill>
+                  </a:tcPr>
+                </a:tc>
+              </a:tr>
+              <a:tr h="548640">
+                <a:tc>
+                  <a:txBody>
+                    <a:bodyPr/>
+                    <a:lstStyle/>
+                    <a:p>
+                      <a:pPr>
+                        <a:defRPr sz="900">
+                          <a:solidFill>
+                            <a:srgbClr val="333333"/>
+                          </a:solidFill>
+                          <a:latin typeface="Calibri"/>
+                        </a:defRPr>
+                      </a:pPr>
+                      <a:r>
+                        <a:t>1</a:t>
+                      </a:r>
+                    </a:p>
+                  </a:txBody>
+                  <a:tcPr>
+                    <a:solidFill>
+                      <a:srgbClr val="FFFFFF"/>
+                    </a:solidFill>
+                  </a:tcPr>
+                </a:tc>
+                <a:tc>
+                  <a:txBody>
+                    <a:bodyPr/>
+                    <a:lstStyle/>
+                    <a:p>
+                      <a:pPr>
+                        <a:defRPr sz="900" b="1">
+                          <a:solidFill>
+                            <a:srgbClr val="CC9900"/>
+                          </a:solidFill>
+                          <a:latin typeface="Calibri"/>
+                        </a:defRPr>
+                      </a:pPr>
+                      <a:r>
+                        <a:t>MEDIUM</a:t>
+                      </a:r>
+                    </a:p>
+                  </a:txBody>
+                  <a:tcPr>
+                    <a:solidFill>
+                      <a:srgbClr val="FFFFFF"/>
+                    </a:solidFill>
+                  </a:tcPr>
+                </a:tc>
+                <a:tc>
+                  <a:txBody>
+                    <a:bodyPr/>
+                    <a:lstStyle/>
+                    <a:p>
+                      <a:pPr>
+                        <a:defRPr sz="900">
+                          <a:solidFill>
+                            <a:srgbClr val="333333"/>
+                          </a:solidFill>
+                          <a:latin typeface="Calibri"/>
+                        </a:defRPr>
+                      </a:pPr>
+                      <a:r>
+                        <a:t>`SELECT *` from TVARVC (unnecessary wide fetch)</a:t>
+                      </a:r>
+                    </a:p>
+                  </a:txBody>
+                  <a:tcPr>
+                    <a:solidFill>
+                      <a:srgbClr val="FFFFFF"/>
+                    </a:solidFill>
+                  </a:tcPr>
+                </a:tc>
+                <a:tc>
+                  <a:txBody>
+                    <a:bodyPr/>
+                    <a:lstStyle/>
+                    <a:p>
+                      <a:pPr>
+                        <a:defRPr sz="900">
+                          <a:solidFill>
+                            <a:srgbClr val="333333"/>
+                          </a:solidFill>
+                          <a:latin typeface="Consolas"/>
+                        </a:defRPr>
+                      </a:pPr>
+                      <a:r>
+                        <a:t>ZDMS_UPLOAD_FILES_F01:~120</a:t>
+                      </a:r>
+                    </a:p>
+                  </a:txBody>
+                  <a:tcPr>
+                    <a:solidFill>
+                      <a:srgbClr val="FFFFFF"/>
+                    </a:solidFill>
+                  </a:tcPr>
+                </a:tc>
+              </a:tr>
+              <a:tr h="548640">
+                <a:tc>
+                  <a:txBody>
+                    <a:bodyPr/>
+                    <a:lstStyle/>
+                    <a:p>
+                      <a:pPr>
+                        <a:defRPr sz="900">
+                          <a:solidFill>
+                            <a:srgbClr val="333333"/>
+                          </a:solidFill>
+                          <a:latin typeface="Calibri"/>
+                        </a:defRPr>
+                      </a:pPr>
+                      <a:r>
+                        <a:t>2</a:t>
+                      </a:r>
+                    </a:p>
+                  </a:txBody>
+                  <a:tcPr>
+                    <a:solidFill>
+                      <a:srgbClr val="F5F5F5"/>
+                    </a:solidFill>
+                  </a:tcPr>
+                </a:tc>
+                <a:tc>
+                  <a:txBody>
+                    <a:bodyPr/>
+                    <a:lstStyle/>
+                    <a:p>
+                      <a:pPr>
+                        <a:defRPr sz="900" b="1">
+                          <a:solidFill>
+                            <a:srgbClr val="CC9900"/>
+                          </a:solidFill>
+                          <a:latin typeface="Calibri"/>
+                        </a:defRPr>
+                      </a:pPr>
+                      <a:r>
+                        <a:t>MEDIUM</a:t>
+                      </a:r>
+                    </a:p>
+                  </a:txBody>
+                  <a:tcPr>
+                    <a:solidFill>
+                      <a:srgbClr val="F5F5F5"/>
+                    </a:solidFill>
+                  </a:tcPr>
+                </a:tc>
+                <a:tc>
+                  <a:txBody>
+                    <a:bodyPr/>
+                    <a:lstStyle/>
+                    <a:p>
+                      <a:pPr>
+                        <a:defRPr sz="900">
+                          <a:solidFill>
+                            <a:srgbClr val="333333"/>
+                          </a:solidFill>
+                          <a:latin typeface="Calibri"/>
+                        </a:defRPr>
+                      </a:pPr>
+                      <a:r>
+                        <a:t>`SELECT *` from DMS_DOC_FILES (potentially wide table)</a:t>
+                      </a:r>
+                    </a:p>
+                  </a:txBody>
+                  <a:tcPr>
+                    <a:solidFill>
+                      <a:srgbClr val="F5F5F5"/>
+                    </a:solidFill>
+                  </a:tcPr>
+                </a:tc>
+                <a:tc>
+                  <a:txBody>
+                    <a:bodyPr/>
+                    <a:lstStyle/>
+                    <a:p>
+                      <a:pPr>
+                        <a:defRPr sz="900">
+                          <a:solidFill>
+                            <a:srgbClr val="333333"/>
+                          </a:solidFill>
+                          <a:latin typeface="Consolas"/>
+                        </a:defRPr>
+                      </a:pPr>
+                      <a:r>
+                        <a:t>ZDMS_UPLOAD_FILES_F01:~150</a:t>
+                      </a:r>
+                    </a:p>
+                  </a:txBody>
+                  <a:tcPr>
+                    <a:solidFill>
+                      <a:srgbClr val="F5F5F5"/>
+                    </a:solidFill>
+                  </a:tcPr>
+                </a:tc>
+              </a:tr>
+              <a:tr h="548640">
+                <a:tc>
+                  <a:txBody>
+                    <a:bodyPr/>
+                    <a:lstStyle/>
+                    <a:p>
+                      <a:pPr>
+                        <a:defRPr sz="900">
+                          <a:solidFill>
+                            <a:srgbClr val="333333"/>
+                          </a:solidFill>
+                          <a:latin typeface="Calibri"/>
+                        </a:defRPr>
+                      </a:pPr>
+                      <a:r>
+                        <a:t>3</a:t>
+                      </a:r>
+                    </a:p>
+                  </a:txBody>
+                  <a:tcPr>
+                    <a:solidFill>
+                      <a:srgbClr val="FFFFFF"/>
+                    </a:solidFill>
+                  </a:tcPr>
+                </a:tc>
+                <a:tc>
+                  <a:txBody>
+                    <a:bodyPr/>
+                    <a:lstStyle/>
+                    <a:p>
+                      <a:pPr>
+                        <a:defRPr sz="900" b="1">
+                          <a:solidFill>
+                            <a:srgbClr val="E67E22"/>
+                          </a:solidFill>
+                          <a:latin typeface="Calibri"/>
+                        </a:defRPr>
+                      </a:pPr>
+                      <a:r>
+                        <a:t>HIGH</a:t>
+                      </a:r>
+                    </a:p>
+                  </a:txBody>
+                  <a:tcPr>
+                    <a:solidFill>
+                      <a:srgbClr val="FFFFFF"/>
+                    </a:solidFill>
+                  </a:tcPr>
+                </a:tc>
+                <a:tc>
+                  <a:txBody>
+                    <a:bodyPr/>
+                    <a:lstStyle/>
+                    <a:p>
+                      <a:pPr>
+                        <a:defRPr sz="900">
+                          <a:solidFill>
+                            <a:srgbClr val="333333"/>
+                          </a:solidFill>
+                          <a:latin typeface="Calibri"/>
+                        </a:defRPr>
+                      </a:pPr>
+                      <a:r>
+                        <a:t>Repeated function/module calls inside loop (FORMAT_MESSAGE)</a:t>
+                      </a:r>
+                    </a:p>
+                  </a:txBody>
+                  <a:tcPr>
+                    <a:solidFill>
+                      <a:srgbClr val="FFFFFF"/>
+                    </a:solidFill>
+                  </a:tcPr>
+                </a:tc>
+                <a:tc>
+                  <a:txBody>
+                    <a:bodyPr/>
+                    <a:lstStyle/>
+                    <a:p>
+                      <a:pPr>
+                        <a:defRPr sz="900">
+                          <a:solidFill>
+                            <a:srgbClr val="333333"/>
+                          </a:solidFill>
+                          <a:latin typeface="Consolas"/>
+                        </a:defRPr>
+                      </a:pPr>
+                      <a:r>
+                        <a:t>ZDMS_UPLOAD_FILES_F01:~235</a:t>
+                      </a:r>
+                    </a:p>
+                  </a:txBody>
+                  <a:tcPr>
+                    <a:solidFill>
+                      <a:srgbClr val="FFFFFF"/>
+                    </a:solidFill>
+                  </a:tcPr>
+                </a:tc>
+              </a:tr>
+              <a:tr h="548640">
+                <a:tc>
+                  <a:txBody>
+                    <a:bodyPr/>
+                    <a:lstStyle/>
+                    <a:p>
+                      <a:pPr>
+                        <a:defRPr sz="900">
+                          <a:solidFill>
+                            <a:srgbClr val="333333"/>
+                          </a:solidFill>
+                          <a:latin typeface="Calibri"/>
+                        </a:defRPr>
+                      </a:pPr>
+                      <a:r>
+                        <a:t>4</a:t>
+                      </a:r>
+                    </a:p>
+                  </a:txBody>
+                  <a:tcPr>
+                    <a:solidFill>
+                      <a:srgbClr val="F5F5F5"/>
+                    </a:solidFill>
+                  </a:tcPr>
+                </a:tc>
+                <a:tc>
+                  <a:txBody>
+                    <a:bodyPr/>
+                    <a:lstStyle/>
+                    <a:p>
+                      <a:pPr>
+                        <a:defRPr sz="900" b="1">
+                          <a:solidFill>
+                            <a:srgbClr val="E67E22"/>
+                          </a:solidFill>
+                          <a:latin typeface="Calibri"/>
+                        </a:defRPr>
+                      </a:pPr>
+                      <a:r>
+                        <a:t>HIGH</a:t>
+                      </a:r>
+                    </a:p>
+                  </a:txBody>
+                  <a:tcPr>
+                    <a:solidFill>
+                      <a:srgbClr val="F5F5F5"/>
+                    </a:solidFill>
+                  </a:tcPr>
+                </a:tc>
+                <a:tc>
+                  <a:txBody>
+                    <a:bodyPr/>
+                    <a:lstStyle/>
+                    <a:p>
+                      <a:pPr>
+                        <a:defRPr sz="900">
+                          <a:solidFill>
+                            <a:srgbClr val="333333"/>
+                          </a:solidFill>
+                          <a:latin typeface="Calibri"/>
+                        </a:defRPr>
+                      </a:pPr>
+                      <a:r>
+                        <a:t>Repeated function/module calls inside loop (ZDMS_UPLOAD_DOCUMENTS)</a:t>
+                      </a:r>
+                    </a:p>
+                  </a:txBody>
+                  <a:tcPr>
+                    <a:solidFill>
+                      <a:srgbClr val="F5F5F5"/>
+                    </a:solidFill>
+                  </a:tcPr>
+                </a:tc>
+                <a:tc>
+                  <a:txBody>
+                    <a:bodyPr/>
+                    <a:lstStyle/>
+                    <a:p>
+                      <a:pPr>
+                        <a:defRPr sz="900">
+                          <a:solidFill>
+                            <a:srgbClr val="333333"/>
+                          </a:solidFill>
+                          <a:latin typeface="Consolas"/>
+                        </a:defRPr>
+                      </a:pPr>
+                      <a:r>
+                        <a:t>ZDMS_UPLOAD_FILES_F01:~205</a:t>
+                      </a:r>
+                    </a:p>
+                  </a:txBody>
+                  <a:tcPr>
+                    <a:solidFill>
+                      <a:srgbClr val="F5F5F5"/>
+                    </a:solidFill>
+                  </a:tcPr>
+                </a:tc>
+              </a:tr>
+            </a:tbl>
+          </a:graphicData>
+        </a:graphic>
+      </p:graphicFrame>
       <p:sp>
         <p:nvSpPr>
           <p:cNvPr id="6" name="TextBox 5"/>
@@ -5969,7 +7548,7 @@
         </p:nvSpPr>
         <p:spPr>
           <a:xfrm>
-            <a:off x="3200400" y="868680"/>
+            <a:off x="3200400" y="3657600"/>
             <a:ext cx="8869680" cy="274320"/>
           </a:xfrm>
           <a:prstGeom prst="rect">
@@ -5984,15 +7563,15 @@
           <a:lstStyle/>
           <a:p>
             <a:pPr>
-              <a:defRPr sz="1000" b="0">
-                <a:solidFill>
-                  <a:srgbClr val="555555"/>
+              <a:defRPr sz="1000" b="1">
+                <a:solidFill>
+                  <a:srgbClr val="E67E22"/>
                 </a:solidFill>
                 <a:latin typeface="Calibri"/>
               </a:defRPr>
             </a:pPr>
             <a:r>
-              <a:t>Source: ZDMS_UPLOAD_FILES_F01:~250</a:t>
+              <a:t>Representative #3 (HIGH): Repeated function/module calls inside loop (FORMAT_MESSAGE)</a:t>
             </a:r>
           </a:p>
         </p:txBody>
@@ -6005,8 +7584,8 @@
         </p:nvSpPr>
         <p:spPr>
           <a:xfrm>
-            <a:off x="3200400" y="1280160"/>
-            <a:ext cx="8869680" cy="2286000"/>
+            <a:off x="3200400" y="4023360"/>
+            <a:ext cx="8869680" cy="1280160"/>
           </a:xfrm>
           <a:prstGeom prst="rect">
             <a:avLst/>
@@ -6022,7 +7601,7 @@
           <a:lstStyle/>
           <a:p>
             <a:pPr>
-              <a:defRPr sz="1200" b="0">
+              <a:defRPr sz="1000" b="0">
                 <a:solidFill>
                   <a:srgbClr val="333333"/>
                 </a:solidFill>
@@ -6030,12 +7609,12 @@
               </a:defRPr>
             </a:pPr>
             <a:r>
-              <a:t>CALL FUNCTION 'SXPG_COMMAND_EXECUTE'</a:t>
+              <a:t>LOOP AT pt_data ASSIGNING FIELD-SYMBOL(&lt;fs_data&gt;).</a:t>
             </a:r>
           </a:p>
           <a:p>
             <a:pPr>
-              <a:defRPr sz="1200" b="0">
+              <a:defRPr sz="1000" b="0">
                 <a:solidFill>
                   <a:srgbClr val="333333"/>
                 </a:solidFill>
@@ -6043,12 +7622,12 @@
               </a:defRPr>
             </a:pPr>
             <a:r>
-              <a:t>  EXPORTING</a:t>
+              <a:t>  ...</a:t>
             </a:r>
           </a:p>
           <a:p>
             <a:pPr>
-              <a:defRPr sz="1200" b="0">
+              <a:defRPr sz="1000" b="0">
                 <a:solidFill>
                   <a:srgbClr val="333333"/>
                 </a:solidFill>
@@ -6056,12 +7635,12 @@
               </a:defRPr>
             </a:pPr>
             <a:r>
-              <a:t>    commandname           = lv_comm</a:t>
+              <a:t>  CALL FUNCTION 'FORMAT_MESSAGE'</a:t>
             </a:r>
           </a:p>
           <a:p>
             <a:pPr>
-              <a:defRPr sz="1200" b="0">
+              <a:defRPr sz="1000" b="0">
                 <a:solidFill>
                   <a:srgbClr val="333333"/>
                 </a:solidFill>
@@ -6069,7 +7648,20 @@
               </a:defRPr>
             </a:pPr>
             <a:r>
-              <a:t>    additional_parameters = gv_param</a:t>
+              <a:t>    EXPORTING</a:t>
+            </a:r>
+          </a:p>
+          <a:p>
+            <a:pPr>
+              <a:defRPr sz="1000" b="0">
+                <a:solidFill>
+                  <a:srgbClr val="333333"/>
+                </a:solidFill>
+                <a:latin typeface="Consolas"/>
+              </a:defRPr>
+            </a:pPr>
+            <a:r>
+              <a:t>      id        = rs_return-id</a:t>
             </a:r>
           </a:p>
         </p:txBody>
@@ -6082,8 +7674,8 @@
         </p:nvSpPr>
         <p:spPr>
           <a:xfrm>
-            <a:off x="3200400" y="4023360"/>
-            <a:ext cx="8869680" cy="914400"/>
+            <a:off x="3200400" y="5486400"/>
+            <a:ext cx="8869680" cy="822960"/>
           </a:xfrm>
           <a:prstGeom prst="rect">
             <a:avLst/>
@@ -6097,7 +7689,7 @@
           <a:lstStyle/>
           <a:p>
             <a:pPr>
-              <a:defRPr sz="1100" b="0">
+              <a:defRPr sz="1000" b="0">
                 <a:solidFill>
                   <a:srgbClr val="333333"/>
                 </a:solidFill>
@@ -6105,7 +7697,30 @@
               </a:defRPr>
             </a:pPr>
             <a:r>
-              <a:t>Why: `SXPG_COMMAND_EXECUTE` triggers execution of an external OS command; there is no explicit `AUTHORITY-CHECK` (e.g., `S_LOG_COM` / `S_RZL_ADM` depending on setup) before this sensitive operation.</a:t>
+              <a:t>Why: Repeated calls to the same function inside a loop can add significant runtime overhead (rule: repeated calls to the same DB / function inside a loop).</a:t>
+            </a:r>
+          </a:p>
+          <a:p>
+            <a:pPr>
+              <a:defRPr sz="1000" b="0">
+                <a:solidFill>
+                  <a:srgbClr val="333333"/>
+                </a:solidFill>
+                <a:latin typeface="Calibri"/>
+              </a:defRPr>
+            </a:pPr>
+          </a:p>
+          <a:p>
+            <a:pPr>
+              <a:defRPr sz="1000" b="0">
+                <a:solidFill>
+                  <a:srgbClr val="333333"/>
+                </a:solidFill>
+                <a:latin typeface="Calibri"/>
+              </a:defRPr>
+            </a:pPr>
+            <a:r>
+              <a:t>Recommendation: Avoid calling `FORMAT_MESSAGE` for every row when possible—e.g., use `rs_return-message` directly if already filled, or collect unique `(id, number, v1..v4)` combinations and format once per unique key (cache result in a hashed table), then reuse.</a:t>
             </a:r>
           </a:p>
         </p:txBody>
@@ -6113,42 +7728,6 @@
       <p:sp>
         <p:nvSpPr>
           <p:cNvPr id="9" name="TextBox 8"/>
-          <p:cNvSpPr txBox="1"/>
-          <p:nvPr/>
-        </p:nvSpPr>
-        <p:spPr>
-          <a:xfrm>
-            <a:off x="3200400" y="5303520"/>
-            <a:ext cx="8869680" cy="1097280"/>
-          </a:xfrm>
-          <a:prstGeom prst="rect">
-            <a:avLst/>
-          </a:prstGeom>
-          <a:noFill/>
-        </p:spPr>
-        <p:txBody>
-          <a:bodyPr wrap="square">
-            <a:spAutoFit/>
-          </a:bodyPr>
-          <a:lstStyle/>
-          <a:p>
-            <a:pPr>
-              <a:defRPr sz="1100" b="1">
-                <a:solidFill>
-                  <a:srgbClr val="418DFF"/>
-                </a:solidFill>
-                <a:latin typeface="Calibri"/>
-              </a:defRPr>
-            </a:pPr>
-            <a:r>
-              <a:t>Recommendation: Add an explicit `AUTHORITY-CHECK` before calling `SXPG_COMMAND_EXECUTE` (and fail closed). Also restrict allowed commands in SM69 and ensure the command is defined with “Additional parameters not allowed” where possible.</a:t>
-            </a:r>
-          </a:p>
-        </p:txBody>
-      </p:sp>
-      <p:sp>
-        <p:nvSpPr>
-          <p:cNvPr id="10" name="TextBox 9"/>
           <p:cNvSpPr txBox="1"/>
           <p:nvPr/>
         </p:nvSpPr>
@@ -6274,7 +7853,7 @@
               </a:defRPr>
             </a:pPr>
             <a:r>
-              <a:t>SECTION 02 · PERFORMANCE</a:t>
+              <a:t>SECTION 02 · MAINTAINABILITY</a:t>
             </a:r>
           </a:p>
         </p:txBody>
@@ -6310,7 +7889,7 @@
               </a:defRPr>
             </a:pPr>
             <a:r>
-              <a:t>Repeated SELECT in loop</a:t>
+              <a:t>All Maintainability findings</a:t>
             </a:r>
           </a:p>
           <a:p>
@@ -6328,248 +7907,1708 @@
               </a:defRPr>
             </a:pPr>
             <a:r>
-              <a:t>Top performance finding</a:t>
-            </a:r>
-          </a:p>
-        </p:txBody>
-      </p:sp>
-      <p:sp>
-        <p:nvSpPr>
-          <p:cNvPr id="5" name="TextBox 4"/>
-          <p:cNvSpPr txBox="1"/>
+              <a:t>16 findings — all LOW, style debt</a:t>
+            </a:r>
+          </a:p>
+        </p:txBody>
+      </p:sp>
+      <p:graphicFrame>
+        <p:nvGraphicFramePr>
+          <p:cNvPr id="5" name="Table 4"/>
+          <p:cNvGraphicFramePr>
+            <a:graphicFrameLocks noGrp="1"/>
+          </p:cNvGraphicFramePr>
           <p:nvPr/>
-        </p:nvSpPr>
-        <p:spPr>
-          <a:xfrm>
-            <a:off x="3200400" y="457200"/>
-            <a:ext cx="8869680" cy="365760"/>
-          </a:xfrm>
-          <a:prstGeom prst="rect">
-            <a:avLst/>
-          </a:prstGeom>
-          <a:noFill/>
-        </p:spPr>
-        <p:txBody>
-          <a:bodyPr wrap="square">
-            <a:spAutoFit/>
-          </a:bodyPr>
-          <a:lstStyle/>
-          <a:p>
-            <a:pPr>
-              <a:defRPr sz="1400" b="1">
-                <a:solidFill>
-                  <a:srgbClr val="C83636"/>
-                </a:solidFill>
-                <a:latin typeface="Calibri"/>
-              </a:defRPr>
-            </a:pPr>
-            <a:r>
-              <a:t>HIGH — Repeated function/module calls inside loop (FORMAT_MESSAGE)</a:t>
-            </a:r>
-          </a:p>
-        </p:txBody>
-      </p:sp>
+        </p:nvGraphicFramePr>
+        <p:xfrm>
+          <a:off x="3200400" y="640080"/>
+          <a:ext cx="8869680" cy="5669280"/>
+        </p:xfrm>
+        <a:graphic>
+          <a:graphicData uri="http://schemas.openxmlformats.org/drawingml/2006/table">
+            <a:tbl>
+              <a:tblPr firstRow="1" bandRow="1">
+                <a:tableStyleId>{5C22544A-7EE6-4342-B048-85BDC9FD1C3A}</a:tableStyleId>
+              </a:tblPr>
+              <a:tblGrid>
+                <a:gridCol w="365760"/>
+                <a:gridCol w="640080"/>
+                <a:gridCol w="5029200"/>
+                <a:gridCol w="2834640"/>
+              </a:tblGrid>
+              <a:tr h="333487">
+                <a:tc>
+                  <a:txBody>
+                    <a:bodyPr/>
+                    <a:lstStyle/>
+                    <a:p>
+                      <a:pPr>
+                        <a:defRPr sz="1000" b="1">
+                          <a:solidFill>
+                            <a:srgbClr val="FFFFFF"/>
+                          </a:solidFill>
+                          <a:latin typeface="Calibri"/>
+                        </a:defRPr>
+                      </a:pPr>
+                      <a:r>
+                        <a:t>#</a:t>
+                      </a:r>
+                    </a:p>
+                  </a:txBody>
+                  <a:tcPr>
+                    <a:solidFill>
+                      <a:srgbClr val="161616"/>
+                    </a:solidFill>
+                  </a:tcPr>
+                </a:tc>
+                <a:tc>
+                  <a:txBody>
+                    <a:bodyPr/>
+                    <a:lstStyle/>
+                    <a:p>
+                      <a:pPr>
+                        <a:defRPr sz="1000" b="1">
+                          <a:solidFill>
+                            <a:srgbClr val="FFFFFF"/>
+                          </a:solidFill>
+                          <a:latin typeface="Calibri"/>
+                        </a:defRPr>
+                      </a:pPr>
+                      <a:r>
+                        <a:t>Sev</a:t>
+                      </a:r>
+                    </a:p>
+                  </a:txBody>
+                  <a:tcPr>
+                    <a:solidFill>
+                      <a:srgbClr val="161616"/>
+                    </a:solidFill>
+                  </a:tcPr>
+                </a:tc>
+                <a:tc>
+                  <a:txBody>
+                    <a:bodyPr/>
+                    <a:lstStyle/>
+                    <a:p>
+                      <a:pPr>
+                        <a:defRPr sz="1000" b="1">
+                          <a:solidFill>
+                            <a:srgbClr val="FFFFFF"/>
+                          </a:solidFill>
+                          <a:latin typeface="Calibri"/>
+                        </a:defRPr>
+                      </a:pPr>
+                      <a:r>
+                        <a:t>Finding title</a:t>
+                      </a:r>
+                    </a:p>
+                  </a:txBody>
+                  <a:tcPr>
+                    <a:solidFill>
+                      <a:srgbClr val="161616"/>
+                    </a:solidFill>
+                  </a:tcPr>
+                </a:tc>
+                <a:tc>
+                  <a:txBody>
+                    <a:bodyPr/>
+                    <a:lstStyle/>
+                    <a:p>
+                      <a:pPr>
+                        <a:defRPr sz="1000" b="1">
+                          <a:solidFill>
+                            <a:srgbClr val="FFFFFF"/>
+                          </a:solidFill>
+                          <a:latin typeface="Calibri"/>
+                        </a:defRPr>
+                      </a:pPr>
+                      <a:r>
+                        <a:t>Location</a:t>
+                      </a:r>
+                    </a:p>
+                  </a:txBody>
+                  <a:tcPr>
+                    <a:solidFill>
+                      <a:srgbClr val="161616"/>
+                    </a:solidFill>
+                  </a:tcPr>
+                </a:tc>
+              </a:tr>
+              <a:tr h="333487">
+                <a:tc>
+                  <a:txBody>
+                    <a:bodyPr/>
+                    <a:lstStyle/>
+                    <a:p>
+                      <a:pPr>
+                        <a:defRPr sz="900">
+                          <a:solidFill>
+                            <a:srgbClr val="333333"/>
+                          </a:solidFill>
+                          <a:latin typeface="Calibri"/>
+                        </a:defRPr>
+                      </a:pPr>
+                      <a:r>
+                        <a:t>1</a:t>
+                      </a:r>
+                    </a:p>
+                  </a:txBody>
+                  <a:tcPr>
+                    <a:solidFill>
+                      <a:srgbClr val="FFFFFF"/>
+                    </a:solidFill>
+                  </a:tcPr>
+                </a:tc>
+                <a:tc>
+                  <a:txBody>
+                    <a:bodyPr/>
+                    <a:lstStyle/>
+                    <a:p>
+                      <a:pPr>
+                        <a:defRPr sz="900" b="1">
+                          <a:solidFill>
+                            <a:srgbClr val="707070"/>
+                          </a:solidFill>
+                          <a:latin typeface="Calibri"/>
+                        </a:defRPr>
+                      </a:pPr>
+                      <a:r>
+                        <a:t>LOW</a:t>
+                      </a:r>
+                    </a:p>
+                  </a:txBody>
+                  <a:tcPr>
+                    <a:solidFill>
+                      <a:srgbClr val="FFFFFF"/>
+                    </a:solidFill>
+                  </a:tcPr>
+                </a:tc>
+                <a:tc>
+                  <a:txBody>
+                    <a:bodyPr/>
+                    <a:lstStyle/>
+                    <a:p>
+                      <a:pPr>
+                        <a:defRPr sz="900">
+                          <a:solidFill>
+                            <a:srgbClr val="333333"/>
+                          </a:solidFill>
+                          <a:latin typeface="Calibri"/>
+                        </a:defRPr>
+                      </a:pPr>
+                      <a:r>
+                        <a:t>Obsolete string building with CONCATENATE</a:t>
+                      </a:r>
+                    </a:p>
+                  </a:txBody>
+                  <a:tcPr>
+                    <a:solidFill>
+                      <a:srgbClr val="FFFFFF"/>
+                    </a:solidFill>
+                  </a:tcPr>
+                </a:tc>
+                <a:tc>
+                  <a:txBody>
+                    <a:bodyPr/>
+                    <a:lstStyle/>
+                    <a:p>
+                      <a:pPr>
+                        <a:defRPr sz="900">
+                          <a:solidFill>
+                            <a:srgbClr val="333333"/>
+                          </a:solidFill>
+                          <a:latin typeface="Consolas"/>
+                        </a:defRPr>
+                      </a:pPr>
+                      <a:r>
+                        <a:t>ZDMS_UPLOAD_FILES_F01:33</a:t>
+                      </a:r>
+                    </a:p>
+                  </a:txBody>
+                  <a:tcPr>
+                    <a:solidFill>
+                      <a:srgbClr val="FFFFFF"/>
+                    </a:solidFill>
+                  </a:tcPr>
+                </a:tc>
+              </a:tr>
+              <a:tr h="333487">
+                <a:tc>
+                  <a:txBody>
+                    <a:bodyPr/>
+                    <a:lstStyle/>
+                    <a:p>
+                      <a:pPr>
+                        <a:defRPr sz="900">
+                          <a:solidFill>
+                            <a:srgbClr val="333333"/>
+                          </a:solidFill>
+                          <a:latin typeface="Calibri"/>
+                        </a:defRPr>
+                      </a:pPr>
+                      <a:r>
+                        <a:t>2</a:t>
+                      </a:r>
+                    </a:p>
+                  </a:txBody>
+                  <a:tcPr>
+                    <a:solidFill>
+                      <a:srgbClr val="F5F5F5"/>
+                    </a:solidFill>
+                  </a:tcPr>
+                </a:tc>
+                <a:tc>
+                  <a:txBody>
+                    <a:bodyPr/>
+                    <a:lstStyle/>
+                    <a:p>
+                      <a:pPr>
+                        <a:defRPr sz="900" b="1">
+                          <a:solidFill>
+                            <a:srgbClr val="707070"/>
+                          </a:solidFill>
+                          <a:latin typeface="Calibri"/>
+                        </a:defRPr>
+                      </a:pPr>
+                      <a:r>
+                        <a:t>LOW</a:t>
+                      </a:r>
+                    </a:p>
+                  </a:txBody>
+                  <a:tcPr>
+                    <a:solidFill>
+                      <a:srgbClr val="F5F5F5"/>
+                    </a:solidFill>
+                  </a:tcPr>
+                </a:tc>
+                <a:tc>
+                  <a:txBody>
+                    <a:bodyPr/>
+                    <a:lstStyle/>
+                    <a:p>
+                      <a:pPr>
+                        <a:defRPr sz="900">
+                          <a:solidFill>
+                            <a:srgbClr val="333333"/>
+                          </a:solidFill>
+                          <a:latin typeface="Calibri"/>
+                        </a:defRPr>
+                      </a:pPr>
+                      <a:r>
+                        <a:t>Magic value for “color” control (unclear semantics)</a:t>
+                      </a:r>
+                    </a:p>
+                  </a:txBody>
+                  <a:tcPr>
+                    <a:solidFill>
+                      <a:srgbClr val="F5F5F5"/>
+                    </a:solidFill>
+                  </a:tcPr>
+                </a:tc>
+                <a:tc>
+                  <a:txBody>
+                    <a:bodyPr/>
+                    <a:lstStyle/>
+                    <a:p>
+                      <a:pPr>
+                        <a:defRPr sz="900">
+                          <a:solidFill>
+                            <a:srgbClr val="333333"/>
+                          </a:solidFill>
+                          <a:latin typeface="Consolas"/>
+                        </a:defRPr>
+                      </a:pPr>
+                      <a:r>
+                        <a:t>ZDMS_UPLOAD_FILES_F01:54</a:t>
+                      </a:r>
+                    </a:p>
+                  </a:txBody>
+                  <a:tcPr>
+                    <a:solidFill>
+                      <a:srgbClr val="F5F5F5"/>
+                    </a:solidFill>
+                  </a:tcPr>
+                </a:tc>
+              </a:tr>
+              <a:tr h="333487">
+                <a:tc>
+                  <a:txBody>
+                    <a:bodyPr/>
+                    <a:lstStyle/>
+                    <a:p>
+                      <a:pPr>
+                        <a:defRPr sz="900">
+                          <a:solidFill>
+                            <a:srgbClr val="333333"/>
+                          </a:solidFill>
+                          <a:latin typeface="Calibri"/>
+                        </a:defRPr>
+                      </a:pPr>
+                      <a:r>
+                        <a:t>3</a:t>
+                      </a:r>
+                    </a:p>
+                  </a:txBody>
+                  <a:tcPr>
+                    <a:solidFill>
+                      <a:srgbClr val="FFFFFF"/>
+                    </a:solidFill>
+                  </a:tcPr>
+                </a:tc>
+                <a:tc>
+                  <a:txBody>
+                    <a:bodyPr/>
+                    <a:lstStyle/>
+                    <a:p>
+                      <a:pPr>
+                        <a:defRPr sz="900" b="1">
+                          <a:solidFill>
+                            <a:srgbClr val="707070"/>
+                          </a:solidFill>
+                          <a:latin typeface="Calibri"/>
+                        </a:defRPr>
+                      </a:pPr>
+                      <a:r>
+                        <a:t>LOW</a:t>
+                      </a:r>
+                    </a:p>
+                  </a:txBody>
+                  <a:tcPr>
+                    <a:solidFill>
+                      <a:srgbClr val="FFFFFF"/>
+                    </a:solidFill>
+                  </a:tcPr>
+                </a:tc>
+                <a:tc>
+                  <a:txBody>
+                    <a:bodyPr/>
+                    <a:lstStyle/>
+                    <a:p>
+                      <a:pPr>
+                        <a:defRPr sz="900">
+                          <a:solidFill>
+                            <a:srgbClr val="333333"/>
+                          </a:solidFill>
+                          <a:latin typeface="Calibri"/>
+                        </a:defRPr>
+                      </a:pPr>
+                      <a:r>
+                        <a:t>Magic literals for color codes</a:t>
+                      </a:r>
+                    </a:p>
+                  </a:txBody>
+                  <a:tcPr>
+                    <a:solidFill>
+                      <a:srgbClr val="FFFFFF"/>
+                    </a:solidFill>
+                  </a:tcPr>
+                </a:tc>
+                <a:tc>
+                  <a:txBody>
+                    <a:bodyPr/>
+                    <a:lstStyle/>
+                    <a:p>
+                      <a:pPr>
+                        <a:defRPr sz="900">
+                          <a:solidFill>
+                            <a:srgbClr val="333333"/>
+                          </a:solidFill>
+                          <a:latin typeface="Consolas"/>
+                        </a:defRPr>
+                      </a:pPr>
+                      <a:r>
+                        <a:t>ZDMS_UPLOAD_FILES_F01:61</a:t>
+                      </a:r>
+                    </a:p>
+                  </a:txBody>
+                  <a:tcPr>
+                    <a:solidFill>
+                      <a:srgbClr val="FFFFFF"/>
+                    </a:solidFill>
+                  </a:tcPr>
+                </a:tc>
+              </a:tr>
+              <a:tr h="333487">
+                <a:tc>
+                  <a:txBody>
+                    <a:bodyPr/>
+                    <a:lstStyle/>
+                    <a:p>
+                      <a:pPr>
+                        <a:defRPr sz="900">
+                          <a:solidFill>
+                            <a:srgbClr val="333333"/>
+                          </a:solidFill>
+                          <a:latin typeface="Calibri"/>
+                        </a:defRPr>
+                      </a:pPr>
+                      <a:r>
+                        <a:t>4</a:t>
+                      </a:r>
+                    </a:p>
+                  </a:txBody>
+                  <a:tcPr>
+                    <a:solidFill>
+                      <a:srgbClr val="F5F5F5"/>
+                    </a:solidFill>
+                  </a:tcPr>
+                </a:tc>
+                <a:tc>
+                  <a:txBody>
+                    <a:bodyPr/>
+                    <a:lstStyle/>
+                    <a:p>
+                      <a:pPr>
+                        <a:defRPr sz="900" b="1">
+                          <a:solidFill>
+                            <a:srgbClr val="707070"/>
+                          </a:solidFill>
+                          <a:latin typeface="Calibri"/>
+                        </a:defRPr>
+                      </a:pPr>
+                      <a:r>
+                        <a:t>LOW</a:t>
+                      </a:r>
+                    </a:p>
+                  </a:txBody>
+                  <a:tcPr>
+                    <a:solidFill>
+                      <a:srgbClr val="F5F5F5"/>
+                    </a:solidFill>
+                  </a:tcPr>
+                </a:tc>
+                <a:tc>
+                  <a:txBody>
+                    <a:bodyPr/>
+                    <a:lstStyle/>
+                    <a:p>
+                      <a:pPr>
+                        <a:defRPr sz="900">
+                          <a:solidFill>
+                            <a:srgbClr val="333333"/>
+                          </a:solidFill>
+                          <a:latin typeface="Calibri"/>
+                        </a:defRPr>
+                      </a:pPr>
+                      <a:r>
+                        <a:t>Obsolete internal table declaration with HEADER LINE</a:t>
+                      </a:r>
+                    </a:p>
+                  </a:txBody>
+                  <a:tcPr>
+                    <a:solidFill>
+                      <a:srgbClr val="F5F5F5"/>
+                    </a:solidFill>
+                  </a:tcPr>
+                </a:tc>
+                <a:tc>
+                  <a:txBody>
+                    <a:bodyPr/>
+                    <a:lstStyle/>
+                    <a:p>
+                      <a:pPr>
+                        <a:defRPr sz="900">
+                          <a:solidFill>
+                            <a:srgbClr val="333333"/>
+                          </a:solidFill>
+                          <a:latin typeface="Consolas"/>
+                        </a:defRPr>
+                      </a:pPr>
+                      <a:r>
+                        <a:t>ZDMS_UPLOAD_FILES_F01:332</a:t>
+                      </a:r>
+                    </a:p>
+                  </a:txBody>
+                  <a:tcPr>
+                    <a:solidFill>
+                      <a:srgbClr val="F5F5F5"/>
+                    </a:solidFill>
+                  </a:tcPr>
+                </a:tc>
+              </a:tr>
+              <a:tr h="333487">
+                <a:tc>
+                  <a:txBody>
+                    <a:bodyPr/>
+                    <a:lstStyle/>
+                    <a:p>
+                      <a:pPr>
+                        <a:defRPr sz="900">
+                          <a:solidFill>
+                            <a:srgbClr val="333333"/>
+                          </a:solidFill>
+                          <a:latin typeface="Calibri"/>
+                        </a:defRPr>
+                      </a:pPr>
+                      <a:r>
+                        <a:t>5</a:t>
+                      </a:r>
+                    </a:p>
+                  </a:txBody>
+                  <a:tcPr>
+                    <a:solidFill>
+                      <a:srgbClr val="FFFFFF"/>
+                    </a:solidFill>
+                  </a:tcPr>
+                </a:tc>
+                <a:tc>
+                  <a:txBody>
+                    <a:bodyPr/>
+                    <a:lstStyle/>
+                    <a:p>
+                      <a:pPr>
+                        <a:defRPr sz="900" b="1">
+                          <a:solidFill>
+                            <a:srgbClr val="707070"/>
+                          </a:solidFill>
+                          <a:latin typeface="Calibri"/>
+                        </a:defRPr>
+                      </a:pPr>
+                      <a:r>
+                        <a:t>LOW</a:t>
+                      </a:r>
+                    </a:p>
+                  </a:txBody>
+                  <a:tcPr>
+                    <a:solidFill>
+                      <a:srgbClr val="FFFFFF"/>
+                    </a:solidFill>
+                  </a:tcPr>
+                </a:tc>
+                <a:tc>
+                  <a:txBody>
+                    <a:bodyPr/>
+                    <a:lstStyle/>
+                    <a:p>
+                      <a:pPr>
+                        <a:defRPr sz="900">
+                          <a:solidFill>
+                            <a:srgbClr val="333333"/>
+                          </a:solidFill>
+                          <a:latin typeface="Calibri"/>
+                        </a:defRPr>
+                      </a:pPr>
+                      <a:r>
+                        <a:t>Obsolete internal table declaration with HEADER LINE (second instance)</a:t>
+                      </a:r>
+                    </a:p>
+                  </a:txBody>
+                  <a:tcPr>
+                    <a:solidFill>
+                      <a:srgbClr val="FFFFFF"/>
+                    </a:solidFill>
+                  </a:tcPr>
+                </a:tc>
+                <a:tc>
+                  <a:txBody>
+                    <a:bodyPr/>
+                    <a:lstStyle/>
+                    <a:p>
+                      <a:pPr>
+                        <a:defRPr sz="900">
+                          <a:solidFill>
+                            <a:srgbClr val="333333"/>
+                          </a:solidFill>
+                          <a:latin typeface="Consolas"/>
+                        </a:defRPr>
+                      </a:pPr>
+                      <a:r>
+                        <a:t>ZDMS_UPLOAD_FILES_F01:411</a:t>
+                      </a:r>
+                    </a:p>
+                  </a:txBody>
+                  <a:tcPr>
+                    <a:solidFill>
+                      <a:srgbClr val="FFFFFF"/>
+                    </a:solidFill>
+                  </a:tcPr>
+                </a:tc>
+              </a:tr>
+              <a:tr h="333487">
+                <a:tc>
+                  <a:txBody>
+                    <a:bodyPr/>
+                    <a:lstStyle/>
+                    <a:p>
+                      <a:pPr>
+                        <a:defRPr sz="900">
+                          <a:solidFill>
+                            <a:srgbClr val="333333"/>
+                          </a:solidFill>
+                          <a:latin typeface="Calibri"/>
+                        </a:defRPr>
+                      </a:pPr>
+                      <a:r>
+                        <a:t>6</a:t>
+                      </a:r>
+                    </a:p>
+                  </a:txBody>
+                  <a:tcPr>
+                    <a:solidFill>
+                      <a:srgbClr val="F5F5F5"/>
+                    </a:solidFill>
+                  </a:tcPr>
+                </a:tc>
+                <a:tc>
+                  <a:txBody>
+                    <a:bodyPr/>
+                    <a:lstStyle/>
+                    <a:p>
+                      <a:pPr>
+                        <a:defRPr sz="900" b="1">
+                          <a:solidFill>
+                            <a:srgbClr val="707070"/>
+                          </a:solidFill>
+                          <a:latin typeface="Calibri"/>
+                        </a:defRPr>
+                      </a:pPr>
+                      <a:r>
+                        <a:t>LOW</a:t>
+                      </a:r>
+                    </a:p>
+                  </a:txBody>
+                  <a:tcPr>
+                    <a:solidFill>
+                      <a:srgbClr val="F5F5F5"/>
+                    </a:solidFill>
+                  </a:tcPr>
+                </a:tc>
+                <a:tc>
+                  <a:txBody>
+                    <a:bodyPr/>
+                    <a:lstStyle/>
+                    <a:p>
+                      <a:pPr>
+                        <a:defRPr sz="900">
+                          <a:solidFill>
+                            <a:srgbClr val="333333"/>
+                          </a:solidFill>
+                          <a:latin typeface="Calibri"/>
+                        </a:defRPr>
+                      </a:pPr>
+                      <a:r>
+                        <a:t>Commented-out code left in place</a:t>
+                      </a:r>
+                    </a:p>
+                  </a:txBody>
+                  <a:tcPr>
+                    <a:solidFill>
+                      <a:srgbClr val="F5F5F5"/>
+                    </a:solidFill>
+                  </a:tcPr>
+                </a:tc>
+                <a:tc>
+                  <a:txBody>
+                    <a:bodyPr/>
+                    <a:lstStyle/>
+                    <a:p>
+                      <a:pPr>
+                        <a:defRPr sz="900">
+                          <a:solidFill>
+                            <a:srgbClr val="333333"/>
+                          </a:solidFill>
+                          <a:latin typeface="Consolas"/>
+                        </a:defRPr>
+                      </a:pPr>
+                      <a:r>
+                        <a:t>ZDMS_UPLOAD_FILES_F01:103</a:t>
+                      </a:r>
+                    </a:p>
+                  </a:txBody>
+                  <a:tcPr>
+                    <a:solidFill>
+                      <a:srgbClr val="F5F5F5"/>
+                    </a:solidFill>
+                  </a:tcPr>
+                </a:tc>
+              </a:tr>
+              <a:tr h="333487">
+                <a:tc>
+                  <a:txBody>
+                    <a:bodyPr/>
+                    <a:lstStyle/>
+                    <a:p>
+                      <a:pPr>
+                        <a:defRPr sz="900">
+                          <a:solidFill>
+                            <a:srgbClr val="333333"/>
+                          </a:solidFill>
+                          <a:latin typeface="Calibri"/>
+                        </a:defRPr>
+                      </a:pPr>
+                      <a:r>
+                        <a:t>7</a:t>
+                      </a:r>
+                    </a:p>
+                  </a:txBody>
+                  <a:tcPr>
+                    <a:solidFill>
+                      <a:srgbClr val="FFFFFF"/>
+                    </a:solidFill>
+                  </a:tcPr>
+                </a:tc>
+                <a:tc>
+                  <a:txBody>
+                    <a:bodyPr/>
+                    <a:lstStyle/>
+                    <a:p>
+                      <a:pPr>
+                        <a:defRPr sz="900" b="1">
+                          <a:solidFill>
+                            <a:srgbClr val="707070"/>
+                          </a:solidFill>
+                          <a:latin typeface="Calibri"/>
+                        </a:defRPr>
+                      </a:pPr>
+                      <a:r>
+                        <a:t>LOW</a:t>
+                      </a:r>
+                    </a:p>
+                  </a:txBody>
+                  <a:tcPr>
+                    <a:solidFill>
+                      <a:srgbClr val="FFFFFF"/>
+                    </a:solidFill>
+                  </a:tcPr>
+                </a:tc>
+                <a:tc>
+                  <a:txBody>
+                    <a:bodyPr/>
+                    <a:lstStyle/>
+                    <a:p>
+                      <a:pPr>
+                        <a:defRPr sz="900">
+                          <a:solidFill>
+                            <a:srgbClr val="333333"/>
+                          </a:solidFill>
+                          <a:latin typeface="Calibri"/>
+                        </a:defRPr>
+                      </a:pPr>
+                      <a:r>
+                        <a:t>Obsolete string parsing with SPLIT</a:t>
+                      </a:r>
+                    </a:p>
+                  </a:txBody>
+                  <a:tcPr>
+                    <a:solidFill>
+                      <a:srgbClr val="FFFFFF"/>
+                    </a:solidFill>
+                  </a:tcPr>
+                </a:tc>
+                <a:tc>
+                  <a:txBody>
+                    <a:bodyPr/>
+                    <a:lstStyle/>
+                    <a:p>
+                      <a:pPr>
+                        <a:defRPr sz="900">
+                          <a:solidFill>
+                            <a:srgbClr val="333333"/>
+                          </a:solidFill>
+                          <a:latin typeface="Consolas"/>
+                        </a:defRPr>
+                      </a:pPr>
+                      <a:r>
+                        <a:t>ZDMS_UPLOAD_FILES_F01:137</a:t>
+                      </a:r>
+                    </a:p>
+                  </a:txBody>
+                  <a:tcPr>
+                    <a:solidFill>
+                      <a:srgbClr val="FFFFFF"/>
+                    </a:solidFill>
+                  </a:tcPr>
+                </a:tc>
+              </a:tr>
+              <a:tr h="333487">
+                <a:tc>
+                  <a:txBody>
+                    <a:bodyPr/>
+                    <a:lstStyle/>
+                    <a:p>
+                      <a:pPr>
+                        <a:defRPr sz="900">
+                          <a:solidFill>
+                            <a:srgbClr val="333333"/>
+                          </a:solidFill>
+                          <a:latin typeface="Calibri"/>
+                        </a:defRPr>
+                      </a:pPr>
+                      <a:r>
+                        <a:t>8</a:t>
+                      </a:r>
+                    </a:p>
+                  </a:txBody>
+                  <a:tcPr>
+                    <a:solidFill>
+                      <a:srgbClr val="F5F5F5"/>
+                    </a:solidFill>
+                  </a:tcPr>
+                </a:tc>
+                <a:tc>
+                  <a:txBody>
+                    <a:bodyPr/>
+                    <a:lstStyle/>
+                    <a:p>
+                      <a:pPr>
+                        <a:defRPr sz="900" b="1">
+                          <a:solidFill>
+                            <a:srgbClr val="707070"/>
+                          </a:solidFill>
+                          <a:latin typeface="Calibri"/>
+                        </a:defRPr>
+                      </a:pPr>
+                      <a:r>
+                        <a:t>LOW</a:t>
+                      </a:r>
+                    </a:p>
+                  </a:txBody>
+                  <a:tcPr>
+                    <a:solidFill>
+                      <a:srgbClr val="F5F5F5"/>
+                    </a:solidFill>
+                  </a:tcPr>
+                </a:tc>
+                <a:tc>
+                  <a:txBody>
+                    <a:bodyPr/>
+                    <a:lstStyle/>
+                    <a:p>
+                      <a:pPr>
+                        <a:defRPr sz="900">
+                          <a:solidFill>
+                            <a:srgbClr val="333333"/>
+                          </a:solidFill>
+                          <a:latin typeface="Calibri"/>
+                        </a:defRPr>
+                      </a:pPr>
+                      <a:r>
+                        <a:t>Dead code: variable declared but never used</a:t>
+                      </a:r>
+                    </a:p>
+                  </a:txBody>
+                  <a:tcPr>
+                    <a:solidFill>
+                      <a:srgbClr val="F5F5F5"/>
+                    </a:solidFill>
+                  </a:tcPr>
+                </a:tc>
+                <a:tc>
+                  <a:txBody>
+                    <a:bodyPr/>
+                    <a:lstStyle/>
+                    <a:p>
+                      <a:pPr>
+                        <a:defRPr sz="900">
+                          <a:solidFill>
+                            <a:srgbClr val="333333"/>
+                          </a:solidFill>
+                          <a:latin typeface="Consolas"/>
+                        </a:defRPr>
+                      </a:pPr>
+                      <a:r>
+                        <a:t>ZDMS_UPLOAD_FILES_F01:90</a:t>
+                      </a:r>
+                    </a:p>
+                  </a:txBody>
+                  <a:tcPr>
+                    <a:solidFill>
+                      <a:srgbClr val="F5F5F5"/>
+                    </a:solidFill>
+                  </a:tcPr>
+                </a:tc>
+              </a:tr>
+              <a:tr h="333487">
+                <a:tc>
+                  <a:txBody>
+                    <a:bodyPr/>
+                    <a:lstStyle/>
+                    <a:p>
+                      <a:pPr>
+                        <a:defRPr sz="900">
+                          <a:solidFill>
+                            <a:srgbClr val="333333"/>
+                          </a:solidFill>
+                          <a:latin typeface="Calibri"/>
+                        </a:defRPr>
+                      </a:pPr>
+                      <a:r>
+                        <a:t>9</a:t>
+                      </a:r>
+                    </a:p>
+                  </a:txBody>
+                  <a:tcPr>
+                    <a:solidFill>
+                      <a:srgbClr val="FFFFFF"/>
+                    </a:solidFill>
+                  </a:tcPr>
+                </a:tc>
+                <a:tc>
+                  <a:txBody>
+                    <a:bodyPr/>
+                    <a:lstStyle/>
+                    <a:p>
+                      <a:pPr>
+                        <a:defRPr sz="900" b="1">
+                          <a:solidFill>
+                            <a:srgbClr val="707070"/>
+                          </a:solidFill>
+                          <a:latin typeface="Calibri"/>
+                        </a:defRPr>
+                      </a:pPr>
+                      <a:r>
+                        <a:t>LOW</a:t>
+                      </a:r>
+                    </a:p>
+                  </a:txBody>
+                  <a:tcPr>
+                    <a:solidFill>
+                      <a:srgbClr val="FFFFFF"/>
+                    </a:solidFill>
+                  </a:tcPr>
+                </a:tc>
+                <a:tc>
+                  <a:txBody>
+                    <a:bodyPr/>
+                    <a:lstStyle/>
+                    <a:p>
+                      <a:pPr>
+                        <a:defRPr sz="900">
+                          <a:solidFill>
+                            <a:srgbClr val="333333"/>
+                          </a:solidFill>
+                          <a:latin typeface="Calibri"/>
+                        </a:defRPr>
+                      </a:pPr>
+                      <a:r>
+                        <a:t>Mixed inline and explicit DATA declarations in same routine</a:t>
+                      </a:r>
+                    </a:p>
+                  </a:txBody>
+                  <a:tcPr>
+                    <a:solidFill>
+                      <a:srgbClr val="FFFFFF"/>
+                    </a:solidFill>
+                  </a:tcPr>
+                </a:tc>
+                <a:tc>
+                  <a:txBody>
+                    <a:bodyPr/>
+                    <a:lstStyle/>
+                    <a:p>
+                      <a:pPr>
+                        <a:defRPr sz="900">
+                          <a:solidFill>
+                            <a:srgbClr val="333333"/>
+                          </a:solidFill>
+                          <a:latin typeface="Consolas"/>
+                        </a:defRPr>
+                      </a:pPr>
+                      <a:r>
+                        <a:t>ZDMS_UPLOAD_FILES_F01:237</a:t>
+                      </a:r>
+                    </a:p>
+                  </a:txBody>
+                  <a:tcPr>
+                    <a:solidFill>
+                      <a:srgbClr val="FFFFFF"/>
+                    </a:solidFill>
+                  </a:tcPr>
+                </a:tc>
+              </a:tr>
+              <a:tr h="333487">
+                <a:tc>
+                  <a:txBody>
+                    <a:bodyPr/>
+                    <a:lstStyle/>
+                    <a:p>
+                      <a:pPr>
+                        <a:defRPr sz="900">
+                          <a:solidFill>
+                            <a:srgbClr val="333333"/>
+                          </a:solidFill>
+                          <a:latin typeface="Calibri"/>
+                        </a:defRPr>
+                      </a:pPr>
+                      <a:r>
+                        <a:t>10</a:t>
+                      </a:r>
+                    </a:p>
+                  </a:txBody>
+                  <a:tcPr>
+                    <a:solidFill>
+                      <a:srgbClr val="F5F5F5"/>
+                    </a:solidFill>
+                  </a:tcPr>
+                </a:tc>
+                <a:tc>
+                  <a:txBody>
+                    <a:bodyPr/>
+                    <a:lstStyle/>
+                    <a:p>
+                      <a:pPr>
+                        <a:defRPr sz="900" b="1">
+                          <a:solidFill>
+                            <a:srgbClr val="707070"/>
+                          </a:solidFill>
+                          <a:latin typeface="Calibri"/>
+                        </a:defRPr>
+                      </a:pPr>
+                      <a:r>
+                        <a:t>LOW</a:t>
+                      </a:r>
+                    </a:p>
+                  </a:txBody>
+                  <a:tcPr>
+                    <a:solidFill>
+                      <a:srgbClr val="F5F5F5"/>
+                    </a:solidFill>
+                  </a:tcPr>
+                </a:tc>
+                <a:tc>
+                  <a:txBody>
+                    <a:bodyPr/>
+                    <a:lstStyle/>
+                    <a:p>
+                      <a:pPr>
+                        <a:defRPr sz="900">
+                          <a:solidFill>
+                            <a:srgbClr val="333333"/>
+                          </a:solidFill>
+                          <a:latin typeface="Calibri"/>
+                        </a:defRPr>
+                      </a:pPr>
+                      <a:r>
+                        <a:t>Magic literals used for business rules / messages</a:t>
+                      </a:r>
+                    </a:p>
+                  </a:txBody>
+                  <a:tcPr>
+                    <a:solidFill>
+                      <a:srgbClr val="F5F5F5"/>
+                    </a:solidFill>
+                  </a:tcPr>
+                </a:tc>
+                <a:tc>
+                  <a:txBody>
+                    <a:bodyPr/>
+                    <a:lstStyle/>
+                    <a:p>
+                      <a:pPr>
+                        <a:defRPr sz="900">
+                          <a:solidFill>
+                            <a:srgbClr val="333333"/>
+                          </a:solidFill>
+                          <a:latin typeface="Consolas"/>
+                        </a:defRPr>
+                      </a:pPr>
+                      <a:r>
+                        <a:t>ZDMS_UPLOAD_FILES_F01:171</a:t>
+                      </a:r>
+                    </a:p>
+                  </a:txBody>
+                  <a:tcPr>
+                    <a:solidFill>
+                      <a:srgbClr val="F5F5F5"/>
+                    </a:solidFill>
+                  </a:tcPr>
+                </a:tc>
+              </a:tr>
+              <a:tr h="333487">
+                <a:tc>
+                  <a:txBody>
+                    <a:bodyPr/>
+                    <a:lstStyle/>
+                    <a:p>
+                      <a:pPr>
+                        <a:defRPr sz="900">
+                          <a:solidFill>
+                            <a:srgbClr val="333333"/>
+                          </a:solidFill>
+                          <a:latin typeface="Calibri"/>
+                        </a:defRPr>
+                      </a:pPr>
+                      <a:r>
+                        <a:t>11</a:t>
+                      </a:r>
+                    </a:p>
+                  </a:txBody>
+                  <a:tcPr>
+                    <a:solidFill>
+                      <a:srgbClr val="FFFFFF"/>
+                    </a:solidFill>
+                  </a:tcPr>
+                </a:tc>
+                <a:tc>
+                  <a:txBody>
+                    <a:bodyPr/>
+                    <a:lstStyle/>
+                    <a:p>
+                      <a:pPr>
+                        <a:defRPr sz="900" b="1">
+                          <a:solidFill>
+                            <a:srgbClr val="707070"/>
+                          </a:solidFill>
+                          <a:latin typeface="Calibri"/>
+                        </a:defRPr>
+                      </a:pPr>
+                      <a:r>
+                        <a:t>LOW</a:t>
+                      </a:r>
+                    </a:p>
+                  </a:txBody>
+                  <a:tcPr>
+                    <a:solidFill>
+                      <a:srgbClr val="FFFFFF"/>
+                    </a:solidFill>
+                  </a:tcPr>
+                </a:tc>
+                <a:tc>
+                  <a:txBody>
+                    <a:bodyPr/>
+                    <a:lstStyle/>
+                    <a:p>
+                      <a:pPr>
+                        <a:defRPr sz="900">
+                          <a:solidFill>
+                            <a:srgbClr val="333333"/>
+                          </a:solidFill>
+                          <a:latin typeface="Calibri"/>
+                        </a:defRPr>
+                      </a:pPr>
+                      <a:r>
+                        <a:t>Obsolete string building with CONCATENATE (message construction)</a:t>
+                      </a:r>
+                    </a:p>
+                  </a:txBody>
+                  <a:tcPr>
+                    <a:solidFill>
+                      <a:srgbClr val="FFFFFF"/>
+                    </a:solidFill>
+                  </a:tcPr>
+                </a:tc>
+                <a:tc>
+                  <a:txBody>
+                    <a:bodyPr/>
+                    <a:lstStyle/>
+                    <a:p>
+                      <a:pPr>
+                        <a:defRPr sz="900">
+                          <a:solidFill>
+                            <a:srgbClr val="333333"/>
+                          </a:solidFill>
+                          <a:latin typeface="Consolas"/>
+                        </a:defRPr>
+                      </a:pPr>
+                      <a:r>
+                        <a:t>ZDMS_UPLOAD_FILES_F01:171</a:t>
+                      </a:r>
+                    </a:p>
+                  </a:txBody>
+                  <a:tcPr>
+                    <a:solidFill>
+                      <a:srgbClr val="FFFFFF"/>
+                    </a:solidFill>
+                  </a:tcPr>
+                </a:tc>
+              </a:tr>
+              <a:tr h="333487">
+                <a:tc>
+                  <a:txBody>
+                    <a:bodyPr/>
+                    <a:lstStyle/>
+                    <a:p>
+                      <a:pPr>
+                        <a:defRPr sz="900">
+                          <a:solidFill>
+                            <a:srgbClr val="333333"/>
+                          </a:solidFill>
+                          <a:latin typeface="Calibri"/>
+                        </a:defRPr>
+                      </a:pPr>
+                      <a:r>
+                        <a:t>12</a:t>
+                      </a:r>
+                    </a:p>
+                  </a:txBody>
+                  <a:tcPr>
+                    <a:solidFill>
+                      <a:srgbClr val="F5F5F5"/>
+                    </a:solidFill>
+                  </a:tcPr>
+                </a:tc>
+                <a:tc>
+                  <a:txBody>
+                    <a:bodyPr/>
+                    <a:lstStyle/>
+                    <a:p>
+                      <a:pPr>
+                        <a:defRPr sz="900" b="1">
+                          <a:solidFill>
+                            <a:srgbClr val="707070"/>
+                          </a:solidFill>
+                          <a:latin typeface="Calibri"/>
+                        </a:defRPr>
+                      </a:pPr>
+                      <a:r>
+                        <a:t>LOW</a:t>
+                      </a:r>
+                    </a:p>
+                  </a:txBody>
+                  <a:tcPr>
+                    <a:solidFill>
+                      <a:srgbClr val="F5F5F5"/>
+                    </a:solidFill>
+                  </a:tcPr>
+                </a:tc>
+                <a:tc>
+                  <a:txBody>
+                    <a:bodyPr/>
+                    <a:lstStyle/>
+                    <a:p>
+                      <a:pPr>
+                        <a:defRPr sz="900">
+                          <a:solidFill>
+                            <a:srgbClr val="333333"/>
+                          </a:solidFill>
+                          <a:latin typeface="Calibri"/>
+                        </a:defRPr>
+                      </a:pPr>
+                      <a:r>
+                        <a:t>Magic constants for document type</a:t>
+                      </a:r>
+                    </a:p>
+                  </a:txBody>
+                  <a:tcPr>
+                    <a:solidFill>
+                      <a:srgbClr val="F5F5F5"/>
+                    </a:solidFill>
+                  </a:tcPr>
+                </a:tc>
+                <a:tc>
+                  <a:txBody>
+                    <a:bodyPr/>
+                    <a:lstStyle/>
+                    <a:p>
+                      <a:pPr>
+                        <a:defRPr sz="900">
+                          <a:solidFill>
+                            <a:srgbClr val="333333"/>
+                          </a:solidFill>
+                          <a:latin typeface="Consolas"/>
+                        </a:defRPr>
+                      </a:pPr>
+                      <a:r>
+                        <a:t>ZDMS_UPLOAD_FILES_F01:237</a:t>
+                      </a:r>
+                    </a:p>
+                  </a:txBody>
+                  <a:tcPr>
+                    <a:solidFill>
+                      <a:srgbClr val="F5F5F5"/>
+                    </a:solidFill>
+                  </a:tcPr>
+                </a:tc>
+              </a:tr>
+              <a:tr h="333487">
+                <a:tc>
+                  <a:txBody>
+                    <a:bodyPr/>
+                    <a:lstStyle/>
+                    <a:p>
+                      <a:pPr>
+                        <a:defRPr sz="900">
+                          <a:solidFill>
+                            <a:srgbClr val="333333"/>
+                          </a:solidFill>
+                          <a:latin typeface="Calibri"/>
+                        </a:defRPr>
+                      </a:pPr>
+                      <a:r>
+                        <a:t>13</a:t>
+                      </a:r>
+                    </a:p>
+                  </a:txBody>
+                  <a:tcPr>
+                    <a:solidFill>
+                      <a:srgbClr val="FFFFFF"/>
+                    </a:solidFill>
+                  </a:tcPr>
+                </a:tc>
+                <a:tc>
+                  <a:txBody>
+                    <a:bodyPr/>
+                    <a:lstStyle/>
+                    <a:p>
+                      <a:pPr>
+                        <a:defRPr sz="900" b="1">
+                          <a:solidFill>
+                            <a:srgbClr val="707070"/>
+                          </a:solidFill>
+                          <a:latin typeface="Calibri"/>
+                        </a:defRPr>
+                      </a:pPr>
+                      <a:r>
+                        <a:t>LOW</a:t>
+                      </a:r>
+                    </a:p>
+                  </a:txBody>
+                  <a:tcPr>
+                    <a:solidFill>
+                      <a:srgbClr val="FFFFFF"/>
+                    </a:solidFill>
+                  </a:tcPr>
+                </a:tc>
+                <a:tc>
+                  <a:txBody>
+                    <a:bodyPr/>
+                    <a:lstStyle/>
+                    <a:p>
+                      <a:pPr>
+                        <a:defRPr sz="900">
+                          <a:solidFill>
+                            <a:srgbClr val="333333"/>
+                          </a:solidFill>
+                          <a:latin typeface="Calibri"/>
+                        </a:defRPr>
+                      </a:pPr>
+                      <a:r>
+                        <a:t>Commented-out ENDIF left behind</a:t>
+                      </a:r>
+                    </a:p>
+                  </a:txBody>
+                  <a:tcPr>
+                    <a:solidFill>
+                      <a:srgbClr val="FFFFFF"/>
+                    </a:solidFill>
+                  </a:tcPr>
+                </a:tc>
+                <a:tc>
+                  <a:txBody>
+                    <a:bodyPr/>
+                    <a:lstStyle/>
+                    <a:p>
+                      <a:pPr>
+                        <a:defRPr sz="900">
+                          <a:solidFill>
+                            <a:srgbClr val="333333"/>
+                          </a:solidFill>
+                          <a:latin typeface="Consolas"/>
+                        </a:defRPr>
+                      </a:pPr>
+                      <a:r>
+                        <a:t>ZDMS_UPLOAD_FILES_F01:192</a:t>
+                      </a:r>
+                    </a:p>
+                  </a:txBody>
+                  <a:tcPr>
+                    <a:solidFill>
+                      <a:srgbClr val="FFFFFF"/>
+                    </a:solidFill>
+                  </a:tcPr>
+                </a:tc>
+              </a:tr>
+              <a:tr h="333487">
+                <a:tc>
+                  <a:txBody>
+                    <a:bodyPr/>
+                    <a:lstStyle/>
+                    <a:p>
+                      <a:pPr>
+                        <a:defRPr sz="900">
+                          <a:solidFill>
+                            <a:srgbClr val="333333"/>
+                          </a:solidFill>
+                          <a:latin typeface="Calibri"/>
+                        </a:defRPr>
+                      </a:pPr>
+                      <a:r>
+                        <a:t>14</a:t>
+                      </a:r>
+                    </a:p>
+                  </a:txBody>
+                  <a:tcPr>
+                    <a:solidFill>
+                      <a:srgbClr val="F5F5F5"/>
+                    </a:solidFill>
+                  </a:tcPr>
+                </a:tc>
+                <a:tc>
+                  <a:txBody>
+                    <a:bodyPr/>
+                    <a:lstStyle/>
+                    <a:p>
+                      <a:pPr>
+                        <a:defRPr sz="900" b="1">
+                          <a:solidFill>
+                            <a:srgbClr val="707070"/>
+                          </a:solidFill>
+                          <a:latin typeface="Calibri"/>
+                        </a:defRPr>
+                      </a:pPr>
+                      <a:r>
+                        <a:t>LOW</a:t>
+                      </a:r>
+                    </a:p>
+                  </a:txBody>
+                  <a:tcPr>
+                    <a:solidFill>
+                      <a:srgbClr val="F5F5F5"/>
+                    </a:solidFill>
+                  </a:tcPr>
+                </a:tc>
+                <a:tc>
+                  <a:txBody>
+                    <a:bodyPr/>
+                    <a:lstStyle/>
+                    <a:p>
+                      <a:pPr>
+                        <a:defRPr sz="900">
+                          <a:solidFill>
+                            <a:srgbClr val="333333"/>
+                          </a:solidFill>
+                          <a:latin typeface="Calibri"/>
+                        </a:defRPr>
+                      </a:pPr>
+                      <a:r>
+                        <a:t>Hard-coded “allowed characters” string (magic literal)</a:t>
+                      </a:r>
+                    </a:p>
+                  </a:txBody>
+                  <a:tcPr>
+                    <a:solidFill>
+                      <a:srgbClr val="F5F5F5"/>
+                    </a:solidFill>
+                  </a:tcPr>
+                </a:tc>
+                <a:tc>
+                  <a:txBody>
+                    <a:bodyPr/>
+                    <a:lstStyle/>
+                    <a:p>
+                      <a:pPr>
+                        <a:defRPr sz="900">
+                          <a:solidFill>
+                            <a:srgbClr val="333333"/>
+                          </a:solidFill>
+                          <a:latin typeface="Consolas"/>
+                        </a:defRPr>
+                      </a:pPr>
+                      <a:r>
+                        <a:t>ZDMS_UPLOAD_FILES_F01:260</a:t>
+                      </a:r>
+                    </a:p>
+                  </a:txBody>
+                  <a:tcPr>
+                    <a:solidFill>
+                      <a:srgbClr val="F5F5F5"/>
+                    </a:solidFill>
+                  </a:tcPr>
+                </a:tc>
+              </a:tr>
+              <a:tr h="333487">
+                <a:tc>
+                  <a:txBody>
+                    <a:bodyPr/>
+                    <a:lstStyle/>
+                    <a:p>
+                      <a:pPr>
+                        <a:defRPr sz="900">
+                          <a:solidFill>
+                            <a:srgbClr val="333333"/>
+                          </a:solidFill>
+                          <a:latin typeface="Calibri"/>
+                        </a:defRPr>
+                      </a:pPr>
+                      <a:r>
+                        <a:t>15</a:t>
+                      </a:r>
+                    </a:p>
+                  </a:txBody>
+                  <a:tcPr>
+                    <a:solidFill>
+                      <a:srgbClr val="FFFFFF"/>
+                    </a:solidFill>
+                  </a:tcPr>
+                </a:tc>
+                <a:tc>
+                  <a:txBody>
+                    <a:bodyPr/>
+                    <a:lstStyle/>
+                    <a:p>
+                      <a:pPr>
+                        <a:defRPr sz="900" b="1">
+                          <a:solidFill>
+                            <a:srgbClr val="707070"/>
+                          </a:solidFill>
+                          <a:latin typeface="Calibri"/>
+                        </a:defRPr>
+                      </a:pPr>
+                      <a:r>
+                        <a:t>LOW</a:t>
+                      </a:r>
+                    </a:p>
+                  </a:txBody>
+                  <a:tcPr>
+                    <a:solidFill>
+                      <a:srgbClr val="FFFFFF"/>
+                    </a:solidFill>
+                  </a:tcPr>
+                </a:tc>
+                <a:tc>
+                  <a:txBody>
+                    <a:bodyPr/>
+                    <a:lstStyle/>
+                    <a:p>
+                      <a:pPr>
+                        <a:defRPr sz="900">
+                          <a:solidFill>
+                            <a:srgbClr val="333333"/>
+                          </a:solidFill>
+                          <a:latin typeface="Calibri"/>
+                        </a:defRPr>
+                      </a:pPr>
+                      <a:r>
+                        <a:t>Obsolete string building with CONCATENATE (path construction)</a:t>
+                      </a:r>
+                    </a:p>
+                  </a:txBody>
+                  <a:tcPr>
+                    <a:solidFill>
+                      <a:srgbClr val="FFFFFF"/>
+                    </a:solidFill>
+                  </a:tcPr>
+                </a:tc>
+                <a:tc>
+                  <a:txBody>
+                    <a:bodyPr/>
+                    <a:lstStyle/>
+                    <a:p>
+                      <a:pPr>
+                        <a:defRPr sz="900">
+                          <a:solidFill>
+                            <a:srgbClr val="333333"/>
+                          </a:solidFill>
+                          <a:latin typeface="Consolas"/>
+                        </a:defRPr>
+                      </a:pPr>
+                      <a:r>
+                        <a:t>ZDMS_UPLOAD_FILES_F01:509</a:t>
+                      </a:r>
+                    </a:p>
+                  </a:txBody>
+                  <a:tcPr>
+                    <a:solidFill>
+                      <a:srgbClr val="FFFFFF"/>
+                    </a:solidFill>
+                  </a:tcPr>
+                </a:tc>
+              </a:tr>
+              <a:tr h="333488">
+                <a:tc>
+                  <a:txBody>
+                    <a:bodyPr/>
+                    <a:lstStyle/>
+                    <a:p>
+                      <a:pPr>
+                        <a:defRPr sz="900">
+                          <a:solidFill>
+                            <a:srgbClr val="333333"/>
+                          </a:solidFill>
+                          <a:latin typeface="Calibri"/>
+                        </a:defRPr>
+                      </a:pPr>
+                      <a:r>
+                        <a:t>16</a:t>
+                      </a:r>
+                    </a:p>
+                  </a:txBody>
+                  <a:tcPr>
+                    <a:solidFill>
+                      <a:srgbClr val="F5F5F5"/>
+                    </a:solidFill>
+                  </a:tcPr>
+                </a:tc>
+                <a:tc>
+                  <a:txBody>
+                    <a:bodyPr/>
+                    <a:lstStyle/>
+                    <a:p>
+                      <a:pPr>
+                        <a:defRPr sz="900" b="1">
+                          <a:solidFill>
+                            <a:srgbClr val="707070"/>
+                          </a:solidFill>
+                          <a:latin typeface="Calibri"/>
+                        </a:defRPr>
+                      </a:pPr>
+                      <a:r>
+                        <a:t>LOW</a:t>
+                      </a:r>
+                    </a:p>
+                  </a:txBody>
+                  <a:tcPr>
+                    <a:solidFill>
+                      <a:srgbClr val="F5F5F5"/>
+                    </a:solidFill>
+                  </a:tcPr>
+                </a:tc>
+                <a:tc>
+                  <a:txBody>
+                    <a:bodyPr/>
+                    <a:lstStyle/>
+                    <a:p>
+                      <a:pPr>
+                        <a:defRPr sz="900">
+                          <a:solidFill>
+                            <a:srgbClr val="333333"/>
+                          </a:solidFill>
+                          <a:latin typeface="Calibri"/>
+                        </a:defRPr>
+                      </a:pPr>
+                      <a:r>
+                        <a:t>Missing typing for FORM parameters (implicit ANY)</a:t>
+                      </a:r>
+                    </a:p>
+                  </a:txBody>
+                  <a:tcPr>
+                    <a:solidFill>
+                      <a:srgbClr val="F5F5F5"/>
+                    </a:solidFill>
+                  </a:tcPr>
+                </a:tc>
+                <a:tc>
+                  <a:txBody>
+                    <a:bodyPr/>
+                    <a:lstStyle/>
+                    <a:p>
+                      <a:pPr>
+                        <a:defRPr sz="900">
+                          <a:solidFill>
+                            <a:srgbClr val="333333"/>
+                          </a:solidFill>
+                          <a:latin typeface="Consolas"/>
+                        </a:defRPr>
+                      </a:pPr>
+                      <a:r>
+                        <a:t>ZDMS_UPLOAD_FILES_F01:579</a:t>
+                      </a:r>
+                    </a:p>
+                  </a:txBody>
+                  <a:tcPr>
+                    <a:solidFill>
+                      <a:srgbClr val="F5F5F5"/>
+                    </a:solidFill>
+                  </a:tcPr>
+                </a:tc>
+              </a:tr>
+            </a:tbl>
+          </a:graphicData>
+        </a:graphic>
+      </p:graphicFrame>
       <p:sp>
         <p:nvSpPr>
           <p:cNvPr id="6" name="TextBox 5"/>
-          <p:cNvSpPr txBox="1"/>
-          <p:nvPr/>
-        </p:nvSpPr>
-        <p:spPr>
-          <a:xfrm>
-            <a:off x="3200400" y="868680"/>
-            <a:ext cx="8869680" cy="274320"/>
-          </a:xfrm>
-          <a:prstGeom prst="rect">
-            <a:avLst/>
-          </a:prstGeom>
-          <a:noFill/>
-        </p:spPr>
-        <p:txBody>
-          <a:bodyPr wrap="square">
-            <a:spAutoFit/>
-          </a:bodyPr>
-          <a:lstStyle/>
-          <a:p>
-            <a:pPr>
-              <a:defRPr sz="1000" b="0">
-                <a:solidFill>
-                  <a:srgbClr val="555555"/>
-                </a:solidFill>
-                <a:latin typeface="Calibri"/>
-              </a:defRPr>
-            </a:pPr>
-            <a:r>
-              <a:t>Source: ZDMS_UPLOAD_FILES_F01:~235</a:t>
-            </a:r>
-          </a:p>
-        </p:txBody>
-      </p:sp>
-      <p:sp>
-        <p:nvSpPr>
-          <p:cNvPr id="7" name="TextBox 6"/>
-          <p:cNvSpPr txBox="1"/>
-          <p:nvPr/>
-        </p:nvSpPr>
-        <p:spPr>
-          <a:xfrm>
-            <a:off x="3200400" y="1280160"/>
-            <a:ext cx="8869680" cy="2286000"/>
-          </a:xfrm>
-          <a:prstGeom prst="rect">
-            <a:avLst/>
-          </a:prstGeom>
-          <a:solidFill>
-            <a:srgbClr val="F5F5F5"/>
-          </a:solidFill>
-        </p:spPr>
-        <p:txBody>
-          <a:bodyPr wrap="square">
-            <a:spAutoFit/>
-          </a:bodyPr>
-          <a:lstStyle/>
-          <a:p>
-            <a:pPr>
-              <a:defRPr sz="1200" b="0">
-                <a:solidFill>
-                  <a:srgbClr val="333333"/>
-                </a:solidFill>
-                <a:latin typeface="Consolas"/>
-              </a:defRPr>
-            </a:pPr>
-            <a:r>
-              <a:t>LOOP AT pt_data ASSIGNING FIELD-SYMBOL(&lt;fs_data&gt;).</a:t>
-            </a:r>
-          </a:p>
-          <a:p>
-            <a:pPr>
-              <a:defRPr sz="1200" b="0">
-                <a:solidFill>
-                  <a:srgbClr val="333333"/>
-                </a:solidFill>
-                <a:latin typeface="Consolas"/>
-              </a:defRPr>
-            </a:pPr>
-            <a:r>
-              <a:t>  ...</a:t>
-            </a:r>
-          </a:p>
-          <a:p>
-            <a:pPr>
-              <a:defRPr sz="1200" b="0">
-                <a:solidFill>
-                  <a:srgbClr val="333333"/>
-                </a:solidFill>
-                <a:latin typeface="Consolas"/>
-              </a:defRPr>
-            </a:pPr>
-            <a:r>
-              <a:t>  CALL FUNCTION 'FORMAT_MESSAGE'</a:t>
-            </a:r>
-          </a:p>
-          <a:p>
-            <a:pPr>
-              <a:defRPr sz="1200" b="0">
-                <a:solidFill>
-                  <a:srgbClr val="333333"/>
-                </a:solidFill>
-                <a:latin typeface="Consolas"/>
-              </a:defRPr>
-            </a:pPr>
-            <a:r>
-              <a:t>    EXPORTING</a:t>
-            </a:r>
-          </a:p>
-          <a:p>
-            <a:pPr>
-              <a:defRPr sz="1200" b="0">
-                <a:solidFill>
-                  <a:srgbClr val="333333"/>
-                </a:solidFill>
-                <a:latin typeface="Consolas"/>
-              </a:defRPr>
-            </a:pPr>
-            <a:r>
-              <a:t>      id        = rs_return-id</a:t>
-            </a:r>
-          </a:p>
-        </p:txBody>
-      </p:sp>
-      <p:sp>
-        <p:nvSpPr>
-          <p:cNvPr id="8" name="TextBox 7"/>
-          <p:cNvSpPr txBox="1"/>
-          <p:nvPr/>
-        </p:nvSpPr>
-        <p:spPr>
-          <a:xfrm>
-            <a:off x="3200400" y="4023360"/>
-            <a:ext cx="8869680" cy="914400"/>
-          </a:xfrm>
-          <a:prstGeom prst="rect">
-            <a:avLst/>
-          </a:prstGeom>
-          <a:noFill/>
-        </p:spPr>
-        <p:txBody>
-          <a:bodyPr wrap="square">
-            <a:spAutoFit/>
-          </a:bodyPr>
-          <a:lstStyle/>
-          <a:p>
-            <a:pPr>
-              <a:defRPr sz="1100" b="0">
-                <a:solidFill>
-                  <a:srgbClr val="333333"/>
-                </a:solidFill>
-                <a:latin typeface="Calibri"/>
-              </a:defRPr>
-            </a:pPr>
-            <a:r>
-              <a:t>Why: Repeated calls to the same function inside a loop can add significant runtime overhead (rule: repeated calls to the same DB / function inside a loop).</a:t>
-            </a:r>
-          </a:p>
-        </p:txBody>
-      </p:sp>
-      <p:sp>
-        <p:nvSpPr>
-          <p:cNvPr id="9" name="TextBox 8"/>
-          <p:cNvSpPr txBox="1"/>
-          <p:nvPr/>
-        </p:nvSpPr>
-        <p:spPr>
-          <a:xfrm>
-            <a:off x="3200400" y="5303520"/>
-            <a:ext cx="8869680" cy="1097280"/>
-          </a:xfrm>
-          <a:prstGeom prst="rect">
-            <a:avLst/>
-          </a:prstGeom>
-          <a:noFill/>
-        </p:spPr>
-        <p:txBody>
-          <a:bodyPr wrap="square">
-            <a:spAutoFit/>
-          </a:bodyPr>
-          <a:lstStyle/>
-          <a:p>
-            <a:pPr>
-              <a:defRPr sz="1100" b="1">
-                <a:solidFill>
-                  <a:srgbClr val="418DFF"/>
-                </a:solidFill>
-                <a:latin typeface="Calibri"/>
-              </a:defRPr>
-            </a:pPr>
-            <a:r>
-              <a:t>Recommendation: Avoid calling `FORMAT_MESSAGE` for every row when possible—e.g., use `rs_return-message` directly if already filled, or collect unique `(id, number, v1..v4)` combinations and format once per unique key (cache result in a hashed table), then reuse.</a:t>
-            </a:r>
-          </a:p>
-        </p:txBody>
-      </p:sp>
-      <p:sp>
-        <p:nvSpPr>
-          <p:cNvPr id="10" name="TextBox 9"/>
           <p:cNvSpPr txBox="1"/>
           <p:nvPr/>
         </p:nvSpPr>
@@ -6612,353 +9651,6 @@
 </file>
 
 <file path=ppt/slides/slide8.xml><?xml version="1.0" encoding="utf-8"?>
-<p:sld xmlns:a="http://schemas.openxmlformats.org/drawingml/2006/main" xmlns:p="http://schemas.openxmlformats.org/presentationml/2006/main" xmlns:r="http://schemas.openxmlformats.org/officeDocument/2006/relationships">
-  <p:cSld>
-    <p:spTree>
-      <p:nvGrpSpPr>
-        <p:cNvPr id="1" name=""/>
-        <p:cNvGrpSpPr/>
-        <p:nvPr/>
-      </p:nvGrpSpPr>
-      <p:grpSpPr/>
-      <p:sp>
-        <p:nvSpPr>
-          <p:cNvPr id="2" name="Rectangle 1"/>
-          <p:cNvSpPr/>
-          <p:nvPr/>
-        </p:nvSpPr>
-        <p:spPr>
-          <a:xfrm>
-            <a:off x="0" y="0"/>
-            <a:ext cx="3017520" cy="6858000"/>
-          </a:xfrm>
-          <a:prstGeom prst="rect">
-            <a:avLst/>
-          </a:prstGeom>
-          <a:solidFill>
-            <a:srgbClr val="EEEEEE"/>
-          </a:solidFill>
-          <a:ln>
-            <a:noFill/>
-          </a:ln>
-        </p:spPr>
-        <p:style>
-          <a:lnRef idx="1">
-            <a:schemeClr val="accent1"/>
-          </a:lnRef>
-          <a:fillRef idx="3">
-            <a:schemeClr val="accent1"/>
-          </a:fillRef>
-          <a:effectRef idx="2">
-            <a:schemeClr val="accent1"/>
-          </a:effectRef>
-          <a:fontRef idx="minor">
-            <a:schemeClr val="lt1"/>
-          </a:fontRef>
-        </p:style>
-        <p:txBody>
-          <a:bodyPr rtlCol="0" anchor="ctr"/>
-          <a:lstStyle/>
-          <a:p>
-            <a:pPr algn="ctr"/>
-          </a:p>
-        </p:txBody>
-      </p:sp>
-      <p:sp>
-        <p:nvSpPr>
-          <p:cNvPr id="3" name="TextBox 2"/>
-          <p:cNvSpPr txBox="1"/>
-          <p:nvPr/>
-        </p:nvSpPr>
-        <p:spPr>
-          <a:xfrm>
-            <a:off x="274320" y="457200"/>
-            <a:ext cx="2651760" cy="365760"/>
-          </a:xfrm>
-          <a:prstGeom prst="rect">
-            <a:avLst/>
-          </a:prstGeom>
-          <a:noFill/>
-        </p:spPr>
-        <p:txBody>
-          <a:bodyPr wrap="none">
-            <a:spAutoFit/>
-          </a:bodyPr>
-          <a:lstStyle/>
-          <a:p>
-            <a:pPr>
-              <a:defRPr sz="1000" b="1">
-                <a:solidFill>
-                  <a:srgbClr val="00B4C8"/>
-                </a:solidFill>
-                <a:latin typeface="Calibri"/>
-              </a:defRPr>
-            </a:pPr>
-            <a:r>
-              <a:t>SECTION 02 · MAINTAINABILITY</a:t>
-            </a:r>
-          </a:p>
-        </p:txBody>
-      </p:sp>
-      <p:sp>
-        <p:nvSpPr>
-          <p:cNvPr id="4" name="TextBox 3"/>
-          <p:cNvSpPr txBox="1"/>
-          <p:nvPr/>
-        </p:nvSpPr>
-        <p:spPr>
-          <a:xfrm>
-            <a:off x="274320" y="914400"/>
-            <a:ext cx="2651760" cy="2011680"/>
-          </a:xfrm>
-          <a:prstGeom prst="rect">
-            <a:avLst/>
-          </a:prstGeom>
-          <a:noFill/>
-        </p:spPr>
-        <p:txBody>
-          <a:bodyPr wrap="square">
-            <a:spAutoFit/>
-          </a:bodyPr>
-          <a:lstStyle/>
-          <a:p>
-            <a:pPr>
-              <a:defRPr sz="2200">
-                <a:solidFill>
-                  <a:srgbClr val="161616"/>
-                </a:solidFill>
-                <a:latin typeface="Calibri Light"/>
-              </a:defRPr>
-            </a:pPr>
-            <a:r>
-              <a:t>Style debt</a:t>
-            </a:r>
-          </a:p>
-          <a:p>
-            <a:pPr>
-              <a:defRPr sz="400"/>
-            </a:pPr>
-          </a:p>
-          <a:p>
-            <a:pPr>
-              <a:defRPr sz="1200" i="1">
-                <a:solidFill>
-                  <a:srgbClr val="555555"/>
-                </a:solidFill>
-                <a:latin typeface="Calibri"/>
-              </a:defRPr>
-            </a:pPr>
-            <a:r>
-              <a:t>16 LOW findings, deferrable</a:t>
-            </a:r>
-          </a:p>
-        </p:txBody>
-      </p:sp>
-      <p:sp>
-        <p:nvSpPr>
-          <p:cNvPr id="5" name="TextBox 4"/>
-          <p:cNvSpPr txBox="1"/>
-          <p:nvPr/>
-        </p:nvSpPr>
-        <p:spPr>
-          <a:xfrm>
-            <a:off x="3200400" y="640080"/>
-            <a:ext cx="8869680" cy="5669280"/>
-          </a:xfrm>
-          <a:prstGeom prst="rect">
-            <a:avLst/>
-          </a:prstGeom>
-          <a:noFill/>
-        </p:spPr>
-        <p:txBody>
-          <a:bodyPr wrap="square">
-            <a:spAutoFit/>
-          </a:bodyPr>
-          <a:lstStyle/>
-          <a:p>
-            <a:pPr>
-              <a:defRPr sz="1200" b="0">
-                <a:solidFill>
-                  <a:srgbClr val="333333"/>
-                </a:solidFill>
-                <a:latin typeface="Calibri"/>
-              </a:defRPr>
-            </a:pPr>
-            <a:r>
-              <a:t>Themes (full list in 05-maintainability.md):</a:t>
-            </a:r>
-          </a:p>
-          <a:p>
-            <a:pPr>
-              <a:defRPr sz="1200" b="0">
-                <a:solidFill>
-                  <a:srgbClr val="333333"/>
-                </a:solidFill>
-                <a:latin typeface="Calibri"/>
-              </a:defRPr>
-            </a:pPr>
-          </a:p>
-          <a:p>
-            <a:pPr>
-              <a:defRPr sz="1200" b="0">
-                <a:solidFill>
-                  <a:srgbClr val="333333"/>
-                </a:solidFill>
-                <a:latin typeface="Calibri"/>
-              </a:defRPr>
-            </a:pPr>
-            <a:r>
-              <a:t>• Obsolete syntax — CONCATENATE / SPLIT instead of string templates (8 instances).</a:t>
-            </a:r>
-          </a:p>
-          <a:p>
-            <a:pPr>
-              <a:defRPr sz="1200" b="0">
-                <a:solidFill>
-                  <a:srgbClr val="333333"/>
-                </a:solidFill>
-                <a:latin typeface="Calibri"/>
-              </a:defRPr>
-            </a:pPr>
-            <a:r>
-              <a:t>• Magic literals — separator characters (' ', ';', '@', ':') hardcoded in PERFORM calls.</a:t>
-            </a:r>
-          </a:p>
-          <a:p>
-            <a:pPr>
-              <a:defRPr sz="1200" b="0">
-                <a:solidFill>
-                  <a:srgbClr val="333333"/>
-                </a:solidFill>
-                <a:latin typeface="Calibri"/>
-              </a:defRPr>
-            </a:pPr>
-            <a:r>
-              <a:t>• Long FORMs without sub-structure — F01 include groups all logic into a few long FORMs.</a:t>
-            </a:r>
-          </a:p>
-          <a:p>
-            <a:pPr>
-              <a:defRPr sz="1200" b="0">
-                <a:solidFill>
-                  <a:srgbClr val="333333"/>
-                </a:solidFill>
-                <a:latin typeface="Calibri"/>
-              </a:defRPr>
-            </a:pPr>
-            <a:r>
-              <a:t>• Missing ABAP Doc on FORMs that take parameters.</a:t>
-            </a:r>
-          </a:p>
-          <a:p>
-            <a:pPr>
-              <a:defRPr sz="1200" b="0">
-                <a:solidFill>
-                  <a:srgbClr val="333333"/>
-                </a:solidFill>
-                <a:latin typeface="Calibri"/>
-              </a:defRPr>
-            </a:pPr>
-            <a:r>
-              <a:t>• Mixed inline / explicit DATA declarations.</a:t>
-            </a:r>
-          </a:p>
-          <a:p>
-            <a:pPr>
-              <a:defRPr sz="1200" b="0">
-                <a:solidFill>
-                  <a:srgbClr val="333333"/>
-                </a:solidFill>
-                <a:latin typeface="Calibri"/>
-              </a:defRPr>
-            </a:pPr>
-            <a:r>
-              <a:t>• Commented-out code blocks left in the include.</a:t>
-            </a:r>
-          </a:p>
-          <a:p>
-            <a:pPr>
-              <a:defRPr sz="1200" b="0">
-                <a:solidFill>
-                  <a:srgbClr val="333333"/>
-                </a:solidFill>
-                <a:latin typeface="Calibri"/>
-              </a:defRPr>
-            </a:pPr>
-            <a:r>
-              <a:t>• Dead local variables (declared, never read).</a:t>
-            </a:r>
-          </a:p>
-          <a:p>
-            <a:pPr>
-              <a:defRPr sz="1200" b="0">
-                <a:solidFill>
-                  <a:srgbClr val="333333"/>
-                </a:solidFill>
-                <a:latin typeface="Calibri"/>
-              </a:defRPr>
-            </a:pPr>
-          </a:p>
-          <a:p>
-            <a:pPr>
-              <a:defRPr sz="1200" b="0">
-                <a:solidFill>
-                  <a:srgbClr val="333333"/>
-                </a:solidFill>
-                <a:latin typeface="Calibri"/>
-              </a:defRPr>
-            </a:pPr>
-            <a:r>
-              <a:t>None block the object's function. Accumulate over time — fix during the next focused maintenance window.</a:t>
-            </a:r>
-          </a:p>
-        </p:txBody>
-      </p:sp>
-      <p:sp>
-        <p:nvSpPr>
-          <p:cNvPr id="6" name="TextBox 5"/>
-          <p:cNvSpPr txBox="1"/>
-          <p:nvPr/>
-        </p:nvSpPr>
-        <p:spPr>
-          <a:xfrm>
-            <a:off x="3200400" y="6537960"/>
-            <a:ext cx="8869680" cy="228600"/>
-          </a:xfrm>
-          <a:prstGeom prst="rect">
-            <a:avLst/>
-          </a:prstGeom>
-          <a:noFill/>
-        </p:spPr>
-        <p:txBody>
-          <a:bodyPr wrap="none">
-            <a:spAutoFit/>
-          </a:bodyPr>
-          <a:lstStyle/>
-          <a:p>
-            <a:pPr>
-              <a:defRPr sz="800" i="1">
-                <a:solidFill>
-                  <a:srgbClr val="555555"/>
-                </a:solidFill>
-                <a:latin typeface="Calibri"/>
-              </a:defRPr>
-            </a:pPr>
-            <a:r>
-              <a:t>EPAM Proprietary &amp; Confidential</a:t>
-            </a:r>
-          </a:p>
-        </p:txBody>
-      </p:sp>
-    </p:spTree>
-  </p:cSld>
-  <p:clrMapOvr>
-    <a:masterClrMapping/>
-  </p:clrMapOvr>
-</p:sld>
-</file>
-
-<file path=ppt/slides/slide9.xml><?xml version="1.0" encoding="utf-8"?>
 <p:sld xmlns:a="http://schemas.openxmlformats.org/drawingml/2006/main" xmlns:p="http://schemas.openxmlformats.org/presentationml/2006/main" xmlns:r="http://schemas.openxmlformats.org/officeDocument/2006/relationships">
   <p:cSld>
     <p:spTree>

</xml_diff>